<commit_message>
Update presentation and sqlite data files
Replace three binary files: the interim thesis PowerPoint and the Infopoint cockpit SQLite databases. Files changed: Diplomarbeit/doc/Dokumente/DA-Zwischenstandspräsentation-Infopoint.pptx, Infopoint/resources/cockpit-data/data/app.sqlite, and Infopoint/resources/cockpit-data/data/system.sqlite. These are binary content updates (presentation and refreshed app/system data).
</commit_message>
<xml_diff>
--- a/Diplomarbeit/doc/Dokumente/DA-Zwischenstandspräsentation-Infopoint.pptx
+++ b/Diplomarbeit/doc/Dokumente/DA-Zwischenstandspräsentation-Infopoint.pptx
@@ -5,10 +5,10 @@
     <p:sldMasterId id="2147483648" r:id="rId4"/>
   </p:sldMasterIdLst>
   <p:notesMasterIdLst>
-    <p:notesMasterId r:id="rId14"/>
+    <p:notesMasterId r:id="rId18"/>
   </p:notesMasterIdLst>
   <p:handoutMasterIdLst>
-    <p:handoutMasterId r:id="rId15"/>
+    <p:handoutMasterId r:id="rId19"/>
   </p:handoutMasterIdLst>
   <p:sldIdLst>
     <p:sldId id="256" r:id="rId5"/>
@@ -17,9 +17,13 @@
     <p:sldId id="2587" r:id="rId8"/>
     <p:sldId id="2599" r:id="rId9"/>
     <p:sldId id="2586" r:id="rId10"/>
-    <p:sldId id="2600" r:id="rId11"/>
-    <p:sldId id="2584" r:id="rId12"/>
-    <p:sldId id="2595" r:id="rId13"/>
+    <p:sldId id="2601" r:id="rId11"/>
+    <p:sldId id="2602" r:id="rId12"/>
+    <p:sldId id="2590" r:id="rId13"/>
+    <p:sldId id="2603" r:id="rId14"/>
+    <p:sldId id="2600" r:id="rId15"/>
+    <p:sldId id="2584" r:id="rId16"/>
+    <p:sldId id="2595" r:id="rId17"/>
   </p:sldIdLst>
   <p:sldSz cx="12192000" cy="6858000"/>
   <p:notesSz cx="7099300" cy="10234613"/>
@@ -154,7 +158,8 @@
 <file path=ppt/revisionInfo.xml><?xml version="1.0" encoding="utf-8"?>
 <p1510:revInfo xmlns:a="http://schemas.openxmlformats.org/drawingml/2006/main" xmlns:r="http://schemas.openxmlformats.org/officeDocument/2006/relationships" xmlns:p1510="http://schemas.microsoft.com/office/powerpoint/2015/10/main">
   <p1510:revLst>
-    <p1510:client id="{5E6F0253-1AA5-3A4D-8184-80E981510AD2}" v="776" dt="2026-02-25T08:54:57.391"/>
+    <p1510:client id="{59D4938D-CFFD-504E-8E74-74686416991A}" v="344" dt="2026-02-25T14:31:09.721"/>
+    <p1510:client id="{5E6F0253-1AA5-3A4D-8184-80E981510AD2}" v="926" dt="2026-02-25T13:31:11.972"/>
     <p1510:client id="{EE0BFA70-742D-471D-95D8-7DEE0DBAC606}" v="180" dt="2026-02-24T16:45:17.558"/>
   </p1510:revLst>
 </p1510:revInfo>
@@ -165,7 +170,7 @@
   <pc:docChgLst>
     <pc:chgData name="Haensler Michael" userId="dda9f915-4129-4dad-90ba-a37fb0d85cd3" providerId="ADAL" clId="{42C45B63-9AB7-5E40-88D3-6D977AD6031F}"/>
     <pc:docChg chg="undo custSel addSld delSld modSld sldOrd">
-      <pc:chgData name="Haensler Michael" userId="dda9f915-4129-4dad-90ba-a37fb0d85cd3" providerId="ADAL" clId="{42C45B63-9AB7-5E40-88D3-6D977AD6031F}" dt="2026-02-25T08:54:57.391" v="1513" actId="2"/>
+      <pc:chgData name="Haensler Michael" userId="dda9f915-4129-4dad-90ba-a37fb0d85cd3" providerId="ADAL" clId="{42C45B63-9AB7-5E40-88D3-6D977AD6031F}" dt="2026-02-25T13:31:11.972" v="1666" actId="20577"/>
       <pc:docMkLst>
         <pc:docMk/>
       </pc:docMkLst>
@@ -185,7 +190,7 @@
         </pc:spChg>
       </pc:sldChg>
       <pc:sldChg chg="addSp delSp modSp add mod">
-        <pc:chgData name="Haensler Michael" userId="dda9f915-4129-4dad-90ba-a37fb0d85cd3" providerId="ADAL" clId="{42C45B63-9AB7-5E40-88D3-6D977AD6031F}" dt="2026-02-25T08:54:53.802" v="1511" actId="2"/>
+        <pc:chgData name="Haensler Michael" userId="dda9f915-4129-4dad-90ba-a37fb0d85cd3" providerId="ADAL" clId="{42C45B63-9AB7-5E40-88D3-6D977AD6031F}" dt="2026-02-25T12:47:56.447" v="1560" actId="20577"/>
         <pc:sldMkLst>
           <pc:docMk/>
           <pc:sldMk cId="1710119030" sldId="2582"/>
@@ -223,7 +228,7 @@
           </ac:spMkLst>
         </pc:spChg>
         <pc:spChg chg="add mod">
-          <ac:chgData name="Haensler Michael" userId="dda9f915-4129-4dad-90ba-a37fb0d85cd3" providerId="ADAL" clId="{42C45B63-9AB7-5E40-88D3-6D977AD6031F}" dt="2026-02-25T08:54:53.802" v="1511" actId="2"/>
+          <ac:chgData name="Haensler Michael" userId="dda9f915-4129-4dad-90ba-a37fb0d85cd3" providerId="ADAL" clId="{42C45B63-9AB7-5E40-88D3-6D977AD6031F}" dt="2026-02-25T12:47:56.447" v="1560" actId="20577"/>
           <ac:spMkLst>
             <pc:docMk/>
             <pc:sldMk cId="1710119030" sldId="2582"/>
@@ -416,12 +421,20 @@
           </ac:spMkLst>
         </pc:spChg>
       </pc:sldChg>
-      <pc:sldChg chg="del">
-        <pc:chgData name="Haensler Michael" userId="dda9f915-4129-4dad-90ba-a37fb0d85cd3" providerId="ADAL" clId="{42C45B63-9AB7-5E40-88D3-6D977AD6031F}" dt="2026-02-25T08:23:23.714" v="1063" actId="2696"/>
+      <pc:sldChg chg="modSp add del mod">
+        <pc:chgData name="Haensler Michael" userId="dda9f915-4129-4dad-90ba-a37fb0d85cd3" providerId="ADAL" clId="{42C45B63-9AB7-5E40-88D3-6D977AD6031F}" dt="2026-02-25T13:27:59.429" v="1592" actId="20577"/>
         <pc:sldMkLst>
           <pc:docMk/>
           <pc:sldMk cId="2991575151" sldId="2590"/>
         </pc:sldMkLst>
+        <pc:spChg chg="mod">
+          <ac:chgData name="Haensler Michael" userId="dda9f915-4129-4dad-90ba-a37fb0d85cd3" providerId="ADAL" clId="{42C45B63-9AB7-5E40-88D3-6D977AD6031F}" dt="2026-02-25T13:27:59.429" v="1592" actId="20577"/>
+          <ac:spMkLst>
+            <pc:docMk/>
+            <pc:sldMk cId="2991575151" sldId="2590"/>
+            <ac:spMk id="2" creationId="{BB3372C5-1394-0BD3-811C-922AD511BFCB}"/>
+          </ac:spMkLst>
+        </pc:spChg>
       </pc:sldChg>
       <pc:sldChg chg="del">
         <pc:chgData name="Haensler Michael" userId="dda9f915-4129-4dad-90ba-a37fb0d85cd3" providerId="ADAL" clId="{42C45B63-9AB7-5E40-88D3-6D977AD6031F}" dt="2026-02-25T08:23:27.790" v="1066" actId="2696"/>
@@ -682,6 +695,100 @@
           <pc:sldMk cId="1520570822" sldId="2601"/>
         </pc:sldMkLst>
       </pc:sldChg>
+      <pc:sldChg chg="addSp delSp modSp new mod">
+        <pc:chgData name="Haensler Michael" userId="dda9f915-4129-4dad-90ba-a37fb0d85cd3" providerId="ADAL" clId="{42C45B63-9AB7-5E40-88D3-6D977AD6031F}" dt="2026-02-25T13:13:15.532" v="1578" actId="14100"/>
+        <pc:sldMkLst>
+          <pc:docMk/>
+          <pc:sldMk cId="3186464633" sldId="2601"/>
+        </pc:sldMkLst>
+        <pc:spChg chg="mod">
+          <ac:chgData name="Haensler Michael" userId="dda9f915-4129-4dad-90ba-a37fb0d85cd3" providerId="ADAL" clId="{42C45B63-9AB7-5E40-88D3-6D977AD6031F}" dt="2026-02-25T12:47:40.068" v="1539" actId="20577"/>
+          <ac:spMkLst>
+            <pc:docMk/>
+            <pc:sldMk cId="3186464633" sldId="2601"/>
+            <ac:spMk id="2" creationId="{237D006D-D692-5219-93D0-7267E5A087A5}"/>
+          </ac:spMkLst>
+        </pc:spChg>
+        <pc:spChg chg="del">
+          <ac:chgData name="Haensler Michael" userId="dda9f915-4129-4dad-90ba-a37fb0d85cd3" providerId="ADAL" clId="{42C45B63-9AB7-5E40-88D3-6D977AD6031F}" dt="2026-02-25T12:55:52.315" v="1562"/>
+          <ac:spMkLst>
+            <pc:docMk/>
+            <pc:sldMk cId="3186464633" sldId="2601"/>
+            <ac:spMk id="3" creationId="{4080C620-664E-B109-37F3-BDFF45A8BD7C}"/>
+          </ac:spMkLst>
+        </pc:spChg>
+        <pc:spChg chg="mod">
+          <ac:chgData name="Haensler Michael" userId="dda9f915-4129-4dad-90ba-a37fb0d85cd3" providerId="ADAL" clId="{42C45B63-9AB7-5E40-88D3-6D977AD6031F}" dt="2026-02-25T12:59:48.309" v="1577"/>
+          <ac:spMkLst>
+            <pc:docMk/>
+            <pc:sldMk cId="3186464633" sldId="2601"/>
+            <ac:spMk id="4" creationId="{0D69777C-0275-D8F0-8251-D1C5092589C0}"/>
+          </ac:spMkLst>
+        </pc:spChg>
+        <pc:picChg chg="add mod ord">
+          <ac:chgData name="Haensler Michael" userId="dda9f915-4129-4dad-90ba-a37fb0d85cd3" providerId="ADAL" clId="{42C45B63-9AB7-5E40-88D3-6D977AD6031F}" dt="2026-02-25T12:59:19.260" v="1576" actId="1076"/>
+          <ac:picMkLst>
+            <pc:docMk/>
+            <pc:sldMk cId="3186464633" sldId="2601"/>
+            <ac:picMk id="7" creationId="{639AE848-D40D-F017-CC2B-057078A36156}"/>
+          </ac:picMkLst>
+        </pc:picChg>
+        <pc:picChg chg="add mod">
+          <ac:chgData name="Haensler Michael" userId="dda9f915-4129-4dad-90ba-a37fb0d85cd3" providerId="ADAL" clId="{42C45B63-9AB7-5E40-88D3-6D977AD6031F}" dt="2026-02-25T13:13:15.532" v="1578" actId="14100"/>
+          <ac:picMkLst>
+            <pc:docMk/>
+            <pc:sldMk cId="3186464633" sldId="2601"/>
+            <ac:picMk id="9" creationId="{82A5C20B-BC4E-6111-8EF3-2B7845E12E0E}"/>
+          </ac:picMkLst>
+        </pc:picChg>
+      </pc:sldChg>
+      <pc:sldChg chg="addSp delSp modSp new mod">
+        <pc:chgData name="Haensler Michael" userId="dda9f915-4129-4dad-90ba-a37fb0d85cd3" providerId="ADAL" clId="{42C45B63-9AB7-5E40-88D3-6D977AD6031F}" dt="2026-02-25T13:31:11.972" v="1666" actId="20577"/>
+        <pc:sldMkLst>
+          <pc:docMk/>
+          <pc:sldMk cId="2285032369" sldId="2602"/>
+        </pc:sldMkLst>
+        <pc:spChg chg="mod">
+          <ac:chgData name="Haensler Michael" userId="dda9f915-4129-4dad-90ba-a37fb0d85cd3" providerId="ADAL" clId="{42C45B63-9AB7-5E40-88D3-6D977AD6031F}" dt="2026-02-25T13:25:46.434" v="1582"/>
+          <ac:spMkLst>
+            <pc:docMk/>
+            <pc:sldMk cId="2285032369" sldId="2602"/>
+            <ac:spMk id="2" creationId="{257528A1-5242-0F4F-4EC6-661C73DF1412}"/>
+          </ac:spMkLst>
+        </pc:spChg>
+        <pc:spChg chg="del">
+          <ac:chgData name="Haensler Michael" userId="dda9f915-4129-4dad-90ba-a37fb0d85cd3" providerId="ADAL" clId="{42C45B63-9AB7-5E40-88D3-6D977AD6031F}" dt="2026-02-25T13:29:31.230" v="1594"/>
+          <ac:spMkLst>
+            <pc:docMk/>
+            <pc:sldMk cId="2285032369" sldId="2602"/>
+            <ac:spMk id="3" creationId="{9D8FA5A1-0CBA-1DF6-C7ED-D416FD7C7A54}"/>
+          </ac:spMkLst>
+        </pc:spChg>
+        <pc:spChg chg="mod">
+          <ac:chgData name="Haensler Michael" userId="dda9f915-4129-4dad-90ba-a37fb0d85cd3" providerId="ADAL" clId="{42C45B63-9AB7-5E40-88D3-6D977AD6031F}" dt="2026-02-25T13:25:40.446" v="1581" actId="20577"/>
+          <ac:spMkLst>
+            <pc:docMk/>
+            <pc:sldMk cId="2285032369" sldId="2602"/>
+            <ac:spMk id="4" creationId="{97F5DC89-ABCF-0AA5-FD33-03CE9E7FE1C0}"/>
+          </ac:spMkLst>
+        </pc:spChg>
+        <pc:spChg chg="add mod">
+          <ac:chgData name="Haensler Michael" userId="dda9f915-4129-4dad-90ba-a37fb0d85cd3" providerId="ADAL" clId="{42C45B63-9AB7-5E40-88D3-6D977AD6031F}" dt="2026-02-25T13:31:11.972" v="1666" actId="20577"/>
+          <ac:spMkLst>
+            <pc:docMk/>
+            <pc:sldMk cId="2285032369" sldId="2602"/>
+            <ac:spMk id="8" creationId="{6A9B9D5B-DF58-3A2C-F8EB-87765A891255}"/>
+          </ac:spMkLst>
+        </pc:spChg>
+        <pc:picChg chg="add mod ord">
+          <ac:chgData name="Haensler Michael" userId="dda9f915-4129-4dad-90ba-a37fb0d85cd3" providerId="ADAL" clId="{42C45B63-9AB7-5E40-88D3-6D977AD6031F}" dt="2026-02-25T13:29:59.772" v="1599" actId="1076"/>
+          <ac:picMkLst>
+            <pc:docMk/>
+            <pc:sldMk cId="2285032369" sldId="2602"/>
+            <ac:picMk id="7" creationId="{2A9EB6FD-91D3-1D58-983F-30F43FD4CA2E}"/>
+          </ac:picMkLst>
+        </pc:picChg>
+      </pc:sldChg>
     </pc:docChg>
   </pc:docChgLst>
   <pc:docChgLst>
@@ -759,6 +866,46 @@
             <ac:picMk id="10" creationId="{216EC163-8DB8-5E8B-F19B-A9CFC693636B}"/>
           </ac:picMkLst>
         </pc:picChg>
+      </pc:sldChg>
+    </pc:docChg>
+  </pc:docChgLst>
+  <pc:docChgLst>
+    <pc:chgData name="Fellegger Lukas" userId="a22a38ce-a7b7-4a62-af0e-48eea1e6566f" providerId="ADAL" clId="{47ACD159-FFA0-53A0-A126-7E74D8854174}"/>
+    <pc:docChg chg="custSel addSld modSld">
+      <pc:chgData name="Fellegger Lukas" userId="a22a38ce-a7b7-4a62-af0e-48eea1e6566f" providerId="ADAL" clId="{47ACD159-FFA0-53A0-A126-7E74D8854174}" dt="2026-02-25T14:31:09.721" v="344" actId="20577"/>
+      <pc:docMkLst>
+        <pc:docMk/>
+      </pc:docMkLst>
+      <pc:sldChg chg="modSp new mod">
+        <pc:chgData name="Fellegger Lukas" userId="a22a38ce-a7b7-4a62-af0e-48eea1e6566f" providerId="ADAL" clId="{47ACD159-FFA0-53A0-A126-7E74D8854174}" dt="2026-02-25T14:31:09.721" v="344" actId="20577"/>
+        <pc:sldMkLst>
+          <pc:docMk/>
+          <pc:sldMk cId="1958629967" sldId="2603"/>
+        </pc:sldMkLst>
+        <pc:spChg chg="mod">
+          <ac:chgData name="Fellegger Lukas" userId="a22a38ce-a7b7-4a62-af0e-48eea1e6566f" providerId="ADAL" clId="{47ACD159-FFA0-53A0-A126-7E74D8854174}" dt="2026-02-25T14:21:09.389" v="20" actId="20577"/>
+          <ac:spMkLst>
+            <pc:docMk/>
+            <pc:sldMk cId="1958629967" sldId="2603"/>
+            <ac:spMk id="2" creationId="{C3F44CE1-6C83-081D-27F2-1BE461B774E8}"/>
+          </ac:spMkLst>
+        </pc:spChg>
+        <pc:spChg chg="mod">
+          <ac:chgData name="Fellegger Lukas" userId="a22a38ce-a7b7-4a62-af0e-48eea1e6566f" providerId="ADAL" clId="{47ACD159-FFA0-53A0-A126-7E74D8854174}" dt="2026-02-25T14:31:09.721" v="344" actId="20577"/>
+          <ac:spMkLst>
+            <pc:docMk/>
+            <pc:sldMk cId="1958629967" sldId="2603"/>
+            <ac:spMk id="3" creationId="{35873E53-F45C-929D-1E5D-1452475FFF2B}"/>
+          </ac:spMkLst>
+        </pc:spChg>
+        <pc:spChg chg="mod">
+          <ac:chgData name="Fellegger Lukas" userId="a22a38ce-a7b7-4a62-af0e-48eea1e6566f" providerId="ADAL" clId="{47ACD159-FFA0-53A0-A126-7E74D8854174}" dt="2026-02-25T14:28:26.116" v="316"/>
+          <ac:spMkLst>
+            <pc:docMk/>
+            <pc:sldMk cId="1958629967" sldId="2603"/>
+            <ac:spMk id="4" creationId="{50972A08-3F43-530C-3E03-C18F01DE0223}"/>
+          </ac:spMkLst>
+        </pc:spChg>
       </pc:sldChg>
     </pc:docChg>
   </pc:docChgLst>
@@ -1483,7 +1630,7 @@
             <a:fld id="{7AA6D168-C717-485B-B0C8-699ECBDF2CFF}" type="slidenum">
               <a:rPr lang="de-AT" smtClean="0"/>
               <a:pPr/>
-              <a:t>9</a:t>
+              <a:t>13</a:t>
             </a:fld>
             <a:endParaRPr lang="de-AT"/>
           </a:p>
@@ -3927,6 +4074,1057 @@
 </p:sld>
 </file>
 
+<file path=ppt/slides/slide10.xml><?xml version="1.0" encoding="utf-8"?>
+<p:sld xmlns:a="http://schemas.openxmlformats.org/drawingml/2006/main" xmlns:r="http://schemas.openxmlformats.org/officeDocument/2006/relationships" xmlns:p="http://schemas.openxmlformats.org/presentationml/2006/main">
+  <p:cSld>
+    <p:spTree>
+      <p:nvGrpSpPr>
+        <p:cNvPr id="1" name=""/>
+        <p:cNvGrpSpPr/>
+        <p:nvPr/>
+      </p:nvGrpSpPr>
+      <p:grpSpPr>
+        <a:xfrm>
+          <a:off x="0" y="0"/>
+          <a:ext cx="0" cy="0"/>
+          <a:chOff x="0" y="0"/>
+          <a:chExt cx="0" cy="0"/>
+        </a:xfrm>
+      </p:grpSpPr>
+      <p:sp>
+        <p:nvSpPr>
+          <p:cNvPr id="2" name="Titel 1">
+            <a:extLst>
+              <a:ext uri="{FF2B5EF4-FFF2-40B4-BE49-F238E27FC236}">
+                <a16:creationId xmlns:a16="http://schemas.microsoft.com/office/drawing/2014/main" id="{C3F44CE1-6C83-081D-27F2-1BE461B774E8}"/>
+              </a:ext>
+            </a:extLst>
+          </p:cNvPr>
+          <p:cNvSpPr>
+            <a:spLocks noGrp="1"/>
+          </p:cNvSpPr>
+          <p:nvPr>
+            <p:ph type="title"/>
+          </p:nvPr>
+        </p:nvSpPr>
+        <p:spPr/>
+        <p:txBody>
+          <a:bodyPr/>
+          <a:lstStyle/>
+          <a:p>
+            <a:r>
+              <a:rPr lang="de-DE"/>
+              <a:t>Ergebnisse Fellegger</a:t>
+            </a:r>
+          </a:p>
+        </p:txBody>
+      </p:sp>
+      <p:sp>
+        <p:nvSpPr>
+          <p:cNvPr id="3" name="Inhaltsplatzhalter 2">
+            <a:extLst>
+              <a:ext uri="{FF2B5EF4-FFF2-40B4-BE49-F238E27FC236}">
+                <a16:creationId xmlns:a16="http://schemas.microsoft.com/office/drawing/2014/main" id="{35873E53-F45C-929D-1E5D-1452475FFF2B}"/>
+              </a:ext>
+            </a:extLst>
+          </p:cNvPr>
+          <p:cNvSpPr>
+            <a:spLocks noGrp="1"/>
+          </p:cNvSpPr>
+          <p:nvPr>
+            <p:ph idx="1"/>
+          </p:nvPr>
+        </p:nvSpPr>
+        <p:spPr/>
+        <p:txBody>
+          <a:bodyPr/>
+          <a:lstStyle/>
+          <a:p>
+            <a:r>
+              <a:rPr lang="de-DE"/>
+              <a:t>Überarbeitung des Designs</a:t>
+            </a:r>
+          </a:p>
+          <a:p>
+            <a:r>
+              <a:rPr lang="de-DE"/>
+              <a:t>Neuigkeiten -&gt; Detailansicht</a:t>
+            </a:r>
+          </a:p>
+          <a:p>
+            <a:r>
+              <a:rPr lang="de-DE"/>
+              <a:t>Lehrer finden -&gt; Lehrer Tagesansicht/Tagesverlauf</a:t>
+            </a:r>
+          </a:p>
+          <a:p>
+            <a:r>
+              <a:rPr lang="de-DE"/>
+              <a:t>Stundenpläne</a:t>
+            </a:r>
+          </a:p>
+          <a:p>
+            <a:pPr lvl="1"/>
+            <a:r>
+              <a:rPr lang="de-DE"/>
+              <a:t>Klassenstundenpläne hinzugefügt</a:t>
+            </a:r>
+          </a:p>
+          <a:p>
+            <a:pPr lvl="1"/>
+            <a:r>
+              <a:rPr lang="de-DE"/>
+              <a:t>Laborstundenpläne hinzugefügt</a:t>
+            </a:r>
+          </a:p>
+          <a:p>
+            <a:r>
+              <a:rPr lang="de-DE"/>
+              <a:t>Kein </a:t>
+            </a:r>
+            <a:r>
+              <a:rPr lang="de-DE" err="1"/>
+              <a:t>Wlan</a:t>
+            </a:r>
+            <a:r>
+              <a:rPr lang="de-DE"/>
+              <a:t> -&gt; Erneut Versuchen Button</a:t>
+            </a:r>
+          </a:p>
+          <a:p>
+            <a:endParaRPr lang="de-DE"/>
+          </a:p>
+          <a:p>
+            <a:pPr lvl="1"/>
+            <a:endParaRPr lang="de-DE"/>
+          </a:p>
+          <a:p>
+            <a:endParaRPr lang="de-DE"/>
+          </a:p>
+        </p:txBody>
+      </p:sp>
+      <p:sp>
+        <p:nvSpPr>
+          <p:cNvPr id="4" name="Fußzeilenplatzhalter 3">
+            <a:extLst>
+              <a:ext uri="{FF2B5EF4-FFF2-40B4-BE49-F238E27FC236}">
+                <a16:creationId xmlns:a16="http://schemas.microsoft.com/office/drawing/2014/main" id="{50972A08-3F43-530C-3E03-C18F01DE0223}"/>
+              </a:ext>
+            </a:extLst>
+          </p:cNvPr>
+          <p:cNvSpPr>
+            <a:spLocks noGrp="1"/>
+          </p:cNvSpPr>
+          <p:nvPr>
+            <p:ph type="ftr" sz="quarter" idx="11"/>
+          </p:nvPr>
+        </p:nvSpPr>
+        <p:spPr/>
+        <p:txBody>
+          <a:bodyPr/>
+          <a:lstStyle/>
+          <a:p>
+            <a:r>
+              <a:rPr lang="de-AT"/>
+              <a:t>Infopoint – </a:t>
+            </a:r>
+            <a:r>
+              <a:rPr lang="de-AT" err="1"/>
+              <a:t>Hänsler</a:t>
+            </a:r>
+            <a:r>
+              <a:rPr lang="de-AT"/>
+              <a:t> – Moser – Fellegger </a:t>
+            </a:r>
+          </a:p>
+        </p:txBody>
+      </p:sp>
+      <p:sp>
+        <p:nvSpPr>
+          <p:cNvPr id="5" name="Foliennummernplatzhalter 4">
+            <a:extLst>
+              <a:ext uri="{FF2B5EF4-FFF2-40B4-BE49-F238E27FC236}">
+                <a16:creationId xmlns:a16="http://schemas.microsoft.com/office/drawing/2014/main" id="{662EE684-7BB8-BC11-EF92-D8945BBCE5D8}"/>
+              </a:ext>
+            </a:extLst>
+          </p:cNvPr>
+          <p:cNvSpPr>
+            <a:spLocks noGrp="1"/>
+          </p:cNvSpPr>
+          <p:nvPr>
+            <p:ph type="sldNum" sz="quarter" idx="12"/>
+          </p:nvPr>
+        </p:nvSpPr>
+        <p:spPr/>
+        <p:txBody>
+          <a:bodyPr/>
+          <a:lstStyle/>
+          <a:p>
+            <a:fld id="{7DCD6803-3BAA-44F6-A698-23D950C9713B}" type="slidenum">
+              <a:rPr lang="de-AT" smtClean="0"/>
+              <a:pPr/>
+              <a:t>10</a:t>
+            </a:fld>
+            <a:endParaRPr lang="de-AT"/>
+          </a:p>
+        </p:txBody>
+      </p:sp>
+    </p:spTree>
+    <p:extLst>
+      <p:ext uri="{BB962C8B-B14F-4D97-AF65-F5344CB8AC3E}">
+        <p14:creationId xmlns:p14="http://schemas.microsoft.com/office/powerpoint/2010/main" val="1958629967"/>
+      </p:ext>
+    </p:extLst>
+  </p:cSld>
+  <p:clrMapOvr>
+    <a:masterClrMapping/>
+  </p:clrMapOvr>
+</p:sld>
+</file>
+
+<file path=ppt/slides/slide11.xml><?xml version="1.0" encoding="utf-8"?>
+<p:sld xmlns:a="http://schemas.openxmlformats.org/drawingml/2006/main" xmlns:r="http://schemas.openxmlformats.org/officeDocument/2006/relationships" xmlns:p="http://schemas.openxmlformats.org/presentationml/2006/main">
+  <p:cSld>
+    <p:spTree>
+      <p:nvGrpSpPr>
+        <p:cNvPr id="1" name="">
+          <a:extLst>
+            <a:ext uri="{FF2B5EF4-FFF2-40B4-BE49-F238E27FC236}">
+              <a16:creationId xmlns:a16="http://schemas.microsoft.com/office/drawing/2014/main" id="{ADB34A0D-25D2-379C-0144-173ABC38F681}"/>
+            </a:ext>
+          </a:extLst>
+        </p:cNvPr>
+        <p:cNvGrpSpPr/>
+        <p:nvPr/>
+      </p:nvGrpSpPr>
+      <p:grpSpPr>
+        <a:xfrm>
+          <a:off x="0" y="0"/>
+          <a:ext cx="0" cy="0"/>
+          <a:chOff x="0" y="0"/>
+          <a:chExt cx="0" cy="0"/>
+        </a:xfrm>
+      </p:grpSpPr>
+      <p:sp>
+        <p:nvSpPr>
+          <p:cNvPr id="2" name="Titel 1">
+            <a:extLst>
+              <a:ext uri="{FF2B5EF4-FFF2-40B4-BE49-F238E27FC236}">
+                <a16:creationId xmlns:a16="http://schemas.microsoft.com/office/drawing/2014/main" id="{7EF54C98-63B2-84F6-11F8-B5AAEB9CEF46}"/>
+              </a:ext>
+            </a:extLst>
+          </p:cNvPr>
+          <p:cNvSpPr>
+            <a:spLocks noGrp="1"/>
+          </p:cNvSpPr>
+          <p:nvPr>
+            <p:ph type="title"/>
+          </p:nvPr>
+        </p:nvSpPr>
+        <p:spPr/>
+        <p:txBody>
+          <a:bodyPr/>
+          <a:lstStyle/>
+          <a:p>
+            <a:r>
+              <a:rPr lang="de-AT"/>
+              <a:t>Vorstellung</a:t>
+            </a:r>
+            <a:endParaRPr lang="de-DE"/>
+          </a:p>
+        </p:txBody>
+      </p:sp>
+      <p:sp>
+        <p:nvSpPr>
+          <p:cNvPr id="4" name="Fußzeilenplatzhalter 3">
+            <a:extLst>
+              <a:ext uri="{FF2B5EF4-FFF2-40B4-BE49-F238E27FC236}">
+                <a16:creationId xmlns:a16="http://schemas.microsoft.com/office/drawing/2014/main" id="{F6D1FB5E-98BA-EEF5-C10F-DFB50DE2966D}"/>
+              </a:ext>
+            </a:extLst>
+          </p:cNvPr>
+          <p:cNvSpPr>
+            <a:spLocks noGrp="1"/>
+          </p:cNvSpPr>
+          <p:nvPr>
+            <p:ph type="ftr" sz="quarter" idx="11"/>
+          </p:nvPr>
+        </p:nvSpPr>
+        <p:spPr/>
+        <p:txBody>
+          <a:bodyPr/>
+          <a:lstStyle/>
+          <a:p>
+            <a:r>
+              <a:rPr lang="de-AT"/>
+              <a:t>Infopoint – Hänsler – Moser – Fellegger</a:t>
+            </a:r>
+          </a:p>
+        </p:txBody>
+      </p:sp>
+      <p:sp>
+        <p:nvSpPr>
+          <p:cNvPr id="5" name="Foliennummernplatzhalter 4">
+            <a:extLst>
+              <a:ext uri="{FF2B5EF4-FFF2-40B4-BE49-F238E27FC236}">
+                <a16:creationId xmlns:a16="http://schemas.microsoft.com/office/drawing/2014/main" id="{46080CEB-0ECE-A4EA-50E4-D85A98DFFEA6}"/>
+              </a:ext>
+            </a:extLst>
+          </p:cNvPr>
+          <p:cNvSpPr>
+            <a:spLocks noGrp="1"/>
+          </p:cNvSpPr>
+          <p:nvPr>
+            <p:ph type="sldNum" sz="quarter" idx="12"/>
+          </p:nvPr>
+        </p:nvSpPr>
+        <p:spPr/>
+        <p:txBody>
+          <a:bodyPr/>
+          <a:lstStyle/>
+          <a:p>
+            <a:fld id="{7DCD6803-3BAA-44F6-A698-23D950C9713B}" type="slidenum">
+              <a:rPr lang="de-AT" smtClean="0"/>
+              <a:pPr/>
+              <a:t>11</a:t>
+            </a:fld>
+            <a:endParaRPr lang="de-AT"/>
+          </a:p>
+        </p:txBody>
+      </p:sp>
+      <p:sp>
+        <p:nvSpPr>
+          <p:cNvPr id="8" name="Rectangle 1026">
+            <a:extLst>
+              <a:ext uri="{FF2B5EF4-FFF2-40B4-BE49-F238E27FC236}">
+                <a16:creationId xmlns:a16="http://schemas.microsoft.com/office/drawing/2014/main" id="{8F4A3BFE-458C-A17D-5B6D-84768E53AEA3}"/>
+              </a:ext>
+            </a:extLst>
+          </p:cNvPr>
+          <p:cNvSpPr txBox="1">
+            <a:spLocks noChangeArrowheads="1"/>
+          </p:cNvSpPr>
+          <p:nvPr/>
+        </p:nvSpPr>
+        <p:spPr>
+          <a:xfrm>
+            <a:off x="4769562" y="2878558"/>
+            <a:ext cx="2652875" cy="550442"/>
+          </a:xfrm>
+          <a:prstGeom prst="rect">
+            <a:avLst/>
+          </a:prstGeom>
+        </p:spPr>
+        <p:txBody>
+          <a:bodyPr/>
+          <a:lstStyle/>
+          <a:p>
+            <a:pPr algn="ctr"/>
+            <a:r>
+              <a:rPr lang="de-AT" sz="4400" b="1">
+                <a:solidFill>
+                  <a:srgbClr val="9BBB59"/>
+                </a:solidFill>
+              </a:rPr>
+              <a:t>Live Demo</a:t>
+            </a:r>
+          </a:p>
+          <a:p>
+            <a:pPr lvl="0" algn="ctr">
+              <a:spcBef>
+                <a:spcPct val="0"/>
+              </a:spcBef>
+              <a:defRPr/>
+            </a:pPr>
+            <a:endParaRPr lang="de-DE" sz="4400">
+              <a:solidFill>
+                <a:srgbClr val="0070C0"/>
+              </a:solidFill>
+            </a:endParaRPr>
+          </a:p>
+        </p:txBody>
+      </p:sp>
+    </p:spTree>
+    <p:extLst>
+      <p:ext uri="{BB962C8B-B14F-4D97-AF65-F5344CB8AC3E}">
+        <p14:creationId xmlns:p14="http://schemas.microsoft.com/office/powerpoint/2010/main" val="219802421"/>
+      </p:ext>
+    </p:extLst>
+  </p:cSld>
+  <p:clrMapOvr>
+    <a:masterClrMapping/>
+  </p:clrMapOvr>
+</p:sld>
+</file>
+
+<file path=ppt/slides/slide12.xml><?xml version="1.0" encoding="utf-8"?>
+<p:sld xmlns:a="http://schemas.openxmlformats.org/drawingml/2006/main" xmlns:r="http://schemas.openxmlformats.org/officeDocument/2006/relationships" xmlns:p="http://schemas.openxmlformats.org/presentationml/2006/main">
+  <p:cSld>
+    <p:spTree>
+      <p:nvGrpSpPr>
+        <p:cNvPr id="1" name=""/>
+        <p:cNvGrpSpPr/>
+        <p:nvPr/>
+      </p:nvGrpSpPr>
+      <p:grpSpPr>
+        <a:xfrm>
+          <a:off x="0" y="0"/>
+          <a:ext cx="0" cy="0"/>
+          <a:chOff x="0" y="0"/>
+          <a:chExt cx="0" cy="0"/>
+        </a:xfrm>
+      </p:grpSpPr>
+      <p:sp>
+        <p:nvSpPr>
+          <p:cNvPr id="2" name="Titel 1">
+            <a:extLst>
+              <a:ext uri="{FF2B5EF4-FFF2-40B4-BE49-F238E27FC236}">
+                <a16:creationId xmlns:a16="http://schemas.microsoft.com/office/drawing/2014/main" id="{E496C6BA-99A1-43F4-92B8-B6D762EF0987}"/>
+              </a:ext>
+            </a:extLst>
+          </p:cNvPr>
+          <p:cNvSpPr>
+            <a:spLocks noGrp="1"/>
+          </p:cNvSpPr>
+          <p:nvPr>
+            <p:ph type="title"/>
+          </p:nvPr>
+        </p:nvSpPr>
+        <p:spPr/>
+        <p:txBody>
+          <a:bodyPr/>
+          <a:lstStyle/>
+          <a:p>
+            <a:r>
+              <a:rPr lang="de-DE"/>
+              <a:t>Literatur</a:t>
+            </a:r>
+            <a:endParaRPr lang="de-AT"/>
+          </a:p>
+        </p:txBody>
+      </p:sp>
+      <p:sp>
+        <p:nvSpPr>
+          <p:cNvPr id="3" name="Inhaltsplatzhalter 2">
+            <a:extLst>
+              <a:ext uri="{FF2B5EF4-FFF2-40B4-BE49-F238E27FC236}">
+                <a16:creationId xmlns:a16="http://schemas.microsoft.com/office/drawing/2014/main" id="{A228378C-21E0-453B-B255-71BAC911E6C0}"/>
+              </a:ext>
+            </a:extLst>
+          </p:cNvPr>
+          <p:cNvSpPr>
+            <a:spLocks noGrp="1"/>
+          </p:cNvSpPr>
+          <p:nvPr>
+            <p:ph idx="1"/>
+          </p:nvPr>
+        </p:nvSpPr>
+        <p:spPr>
+          <a:xfrm>
+            <a:off x="609600" y="1166069"/>
+            <a:ext cx="10972800" cy="4748169"/>
+          </a:xfrm>
+        </p:spPr>
+        <p:txBody>
+          <a:bodyPr vert="horz" lIns="91440" tIns="45720" rIns="91440" bIns="45720" rtlCol="0" anchor="t">
+            <a:normAutofit fontScale="85000" lnSpcReduction="20000"/>
+          </a:bodyPr>
+          <a:lstStyle/>
+          <a:p>
+            <a:pPr>
+              <a:lnSpc>
+                <a:spcPct val="120000"/>
+              </a:lnSpc>
+            </a:pPr>
+            <a:r>
+              <a:rPr lang="de-DE"/>
+              <a:t>Bis dato durchgesehen:</a:t>
+            </a:r>
+            <a:endParaRPr lang="de-AT"/>
+          </a:p>
+          <a:p>
+            <a:pPr lvl="1">
+              <a:lnSpc>
+                <a:spcPct val="120000"/>
+              </a:lnSpc>
+            </a:pPr>
+            <a:r>
+              <a:rPr lang="de-DE">
+                <a:hlinkClick r:id="rId2">
+                  <a:extLst>
+                    <a:ext uri="{A12FA001-AC4F-418D-AE19-62706E023703}">
+                      <ahyp:hlinkClr xmlns:ahyp="http://schemas.microsoft.com/office/drawing/2018/hyperlinkcolor" val="tx"/>
+                    </a:ext>
+                  </a:extLst>
+                </a:hlinkClick>
+              </a:rPr>
+              <a:t>https://epub.uni-regensburg.de/10868/1/Knowledge_Management_und_Kommunikationssysteme.pdf#page=137</a:t>
+            </a:r>
+            <a:r>
+              <a:rPr lang="de-DE"/>
+              <a:t> </a:t>
+            </a:r>
+          </a:p>
+          <a:p>
+            <a:pPr lvl="1">
+              <a:lnSpc>
+                <a:spcPct val="120000"/>
+              </a:lnSpc>
+            </a:pPr>
+            <a:r>
+              <a:rPr lang="de-DE">
+                <a:hlinkClick r:id="rId3">
+                  <a:extLst>
+                    <a:ext uri="{A12FA001-AC4F-418D-AE19-62706E023703}">
+                      <ahyp:hlinkClr xmlns:ahyp="http://schemas.microsoft.com/office/drawing/2018/hyperlinkcolor" val="tx"/>
+                    </a:ext>
+                  </a:extLst>
+                </a:hlinkClick>
+              </a:rPr>
+              <a:t>https://infopoints.com</a:t>
+            </a:r>
+            <a:r>
+              <a:rPr lang="de-DE"/>
+              <a:t> </a:t>
+            </a:r>
+          </a:p>
+          <a:p>
+            <a:pPr lvl="1">
+              <a:lnSpc>
+                <a:spcPct val="120000"/>
+              </a:lnSpc>
+            </a:pPr>
+            <a:r>
+              <a:rPr lang="de-DE">
+                <a:hlinkClick r:id="rId4">
+                  <a:extLst>
+                    <a:ext uri="{A12FA001-AC4F-418D-AE19-62706E023703}">
+                      <ahyp:hlinkClr xmlns:ahyp="http://schemas.microsoft.com/office/drawing/2018/hyperlinkcolor" val="tx"/>
+                    </a:ext>
+                  </a:extLst>
+                </a:hlinkClick>
+              </a:rPr>
+              <a:t>https://www.eca.europa.eu/en/sustainable-development-goals</a:t>
+            </a:r>
+            <a:r>
+              <a:rPr lang="de-DE"/>
+              <a:t> </a:t>
+            </a:r>
+          </a:p>
+          <a:p>
+            <a:pPr lvl="1">
+              <a:lnSpc>
+                <a:spcPct val="120000"/>
+              </a:lnSpc>
+            </a:pPr>
+            <a:r>
+              <a:rPr lang="de-DE">
+                <a:hlinkClick r:id="rId5">
+                  <a:extLst>
+                    <a:ext uri="{A12FA001-AC4F-418D-AE19-62706E023703}">
+                      <ahyp:hlinkClr xmlns:ahyp="http://schemas.microsoft.com/office/drawing/2018/hyperlinkcolor" val="tx"/>
+                    </a:ext>
+                  </a:extLst>
+                </a:hlinkClick>
+              </a:rPr>
+              <a:t>https://helpx.adobe.com/at/xd/user-guide.html</a:t>
+            </a:r>
+            <a:endParaRPr lang="de-DE"/>
+          </a:p>
+          <a:p>
+            <a:pPr lvl="1">
+              <a:lnSpc>
+                <a:spcPct val="120000"/>
+              </a:lnSpc>
+            </a:pPr>
+            <a:r>
+              <a:rPr lang="de-DE">
+                <a:hlinkClick r:id="rId6">
+                  <a:extLst>
+                    <a:ext uri="{A12FA001-AC4F-418D-AE19-62706E023703}">
+                      <ahyp:hlinkClr xmlns:ahyp="http://schemas.microsoft.com/office/drawing/2018/hyperlinkcolor" val="tx"/>
+                    </a:ext>
+                  </a:extLst>
+                </a:hlinkClick>
+              </a:rPr>
+              <a:t>https://react.dev/reference/react</a:t>
+            </a:r>
+            <a:endParaRPr lang="de-DE"/>
+          </a:p>
+          <a:p>
+            <a:pPr lvl="1">
+              <a:lnSpc>
+                <a:spcPct val="120000"/>
+              </a:lnSpc>
+            </a:pPr>
+            <a:r>
+              <a:rPr lang="de-DE">
+                <a:hlinkClick r:id="rId7">
+                  <a:extLst>
+                    <a:ext uri="{A12FA001-AC4F-418D-AE19-62706E023703}">
+                      <ahyp:hlinkClr xmlns:ahyp="http://schemas.microsoft.com/office/drawing/2018/hyperlinkcolor" val="tx"/>
+                    </a:ext>
+                  </a:extLst>
+                </a:hlinkClick>
+              </a:rPr>
+              <a:t>https://vite.dev/guide/features</a:t>
+            </a:r>
+            <a:endParaRPr lang="de-DE"/>
+          </a:p>
+          <a:p>
+            <a:pPr lvl="1">
+              <a:lnSpc>
+                <a:spcPct val="120000"/>
+              </a:lnSpc>
+            </a:pPr>
+            <a:r>
+              <a:rPr lang="de-DE">
+                <a:hlinkClick r:id="rId8">
+                  <a:extLst>
+                    <a:ext uri="{A12FA001-AC4F-418D-AE19-62706E023703}">
+                      <ahyp:hlinkClr xmlns:ahyp="http://schemas.microsoft.com/office/drawing/2018/hyperlinkcolor" val="tx"/>
+                    </a:ext>
+                  </a:extLst>
+                </a:hlinkClick>
+              </a:rPr>
+              <a:t>https://help.untis.at/hc/de/articles/4403351094034-General-documentation-for-integration-partners</a:t>
+            </a:r>
+            <a:endParaRPr lang="de-DE"/>
+          </a:p>
+          <a:p>
+            <a:pPr lvl="1">
+              <a:lnSpc>
+                <a:spcPct val="120000"/>
+              </a:lnSpc>
+            </a:pPr>
+            <a:r>
+              <a:rPr lang="de-DE">
+                <a:hlinkClick r:id="rId9">
+                  <a:extLst>
+                    <a:ext uri="{A12FA001-AC4F-418D-AE19-62706E023703}">
+                      <ahyp:hlinkClr xmlns:ahyp="http://schemas.microsoft.com/office/drawing/2018/hyperlinkcolor" val="tx"/>
+                    </a:ext>
+                  </a:extLst>
+                </a:hlinkClick>
+              </a:rPr>
+              <a:t>https://getcockpit.com/documentation</a:t>
+            </a:r>
+            <a:endParaRPr lang="de-DE"/>
+          </a:p>
+          <a:p>
+            <a:pPr lvl="1">
+              <a:lnSpc>
+                <a:spcPct val="120000"/>
+              </a:lnSpc>
+            </a:pPr>
+            <a:r>
+              <a:rPr lang="de-DE" u="sng"/>
+              <a:t>https://docs.docker.com</a:t>
+            </a:r>
+            <a:br>
+              <a:rPr lang="de-DE"/>
+            </a:br>
+            <a:endParaRPr lang="de-DE"/>
+          </a:p>
+        </p:txBody>
+      </p:sp>
+      <p:sp>
+        <p:nvSpPr>
+          <p:cNvPr id="4" name="Fußzeilenplatzhalter 3">
+            <a:extLst>
+              <a:ext uri="{FF2B5EF4-FFF2-40B4-BE49-F238E27FC236}">
+                <a16:creationId xmlns:a16="http://schemas.microsoft.com/office/drawing/2014/main" id="{8AADA028-308D-430B-A45B-407D875A2351}"/>
+              </a:ext>
+            </a:extLst>
+          </p:cNvPr>
+          <p:cNvSpPr>
+            <a:spLocks noGrp="1"/>
+          </p:cNvSpPr>
+          <p:nvPr>
+            <p:ph type="ftr" sz="quarter" idx="11"/>
+          </p:nvPr>
+        </p:nvSpPr>
+        <p:spPr/>
+        <p:txBody>
+          <a:bodyPr/>
+          <a:lstStyle/>
+          <a:p>
+            <a:r>
+              <a:rPr lang="de-AT"/>
+              <a:t>Infopoint – Hänsler – Moser – Fellegger </a:t>
+            </a:r>
+          </a:p>
+        </p:txBody>
+      </p:sp>
+      <p:sp>
+        <p:nvSpPr>
+          <p:cNvPr id="5" name="Foliennummernplatzhalter 4">
+            <a:extLst>
+              <a:ext uri="{FF2B5EF4-FFF2-40B4-BE49-F238E27FC236}">
+                <a16:creationId xmlns:a16="http://schemas.microsoft.com/office/drawing/2014/main" id="{AB38338F-922C-40A7-B140-637B827703BF}"/>
+              </a:ext>
+            </a:extLst>
+          </p:cNvPr>
+          <p:cNvSpPr>
+            <a:spLocks noGrp="1"/>
+          </p:cNvSpPr>
+          <p:nvPr>
+            <p:ph type="sldNum" sz="quarter" idx="12"/>
+          </p:nvPr>
+        </p:nvSpPr>
+        <p:spPr/>
+        <p:txBody>
+          <a:bodyPr/>
+          <a:lstStyle/>
+          <a:p>
+            <a:fld id="{7DCD6803-3BAA-44F6-A698-23D950C9713B}" type="slidenum">
+              <a:rPr lang="de-AT" smtClean="0"/>
+              <a:pPr/>
+              <a:t>12</a:t>
+            </a:fld>
+            <a:endParaRPr lang="de-AT"/>
+          </a:p>
+        </p:txBody>
+      </p:sp>
+    </p:spTree>
+    <p:extLst>
+      <p:ext uri="{BB962C8B-B14F-4D97-AF65-F5344CB8AC3E}">
+        <p14:creationId xmlns:p14="http://schemas.microsoft.com/office/powerpoint/2010/main" val="2929837528"/>
+      </p:ext>
+    </p:extLst>
+  </p:cSld>
+  <p:clrMapOvr>
+    <a:masterClrMapping/>
+  </p:clrMapOvr>
+</p:sld>
+</file>
+
+<file path=ppt/slides/slide13.xml><?xml version="1.0" encoding="utf-8"?>
+<p:sld xmlns:a="http://schemas.openxmlformats.org/drawingml/2006/main" xmlns:r="http://schemas.openxmlformats.org/officeDocument/2006/relationships" xmlns:p="http://schemas.openxmlformats.org/presentationml/2006/main">
+  <p:cSld>
+    <p:spTree>
+      <p:nvGrpSpPr>
+        <p:cNvPr id="1" name="">
+          <a:extLst>
+            <a:ext uri="{FF2B5EF4-FFF2-40B4-BE49-F238E27FC236}">
+              <a16:creationId xmlns:a16="http://schemas.microsoft.com/office/drawing/2014/main" id="{5F888E23-8483-4BC2-2386-C82FDAF0F799}"/>
+            </a:ext>
+          </a:extLst>
+        </p:cNvPr>
+        <p:cNvGrpSpPr/>
+        <p:nvPr/>
+      </p:nvGrpSpPr>
+      <p:grpSpPr>
+        <a:xfrm>
+          <a:off x="0" y="0"/>
+          <a:ext cx="0" cy="0"/>
+          <a:chOff x="0" y="0"/>
+          <a:chExt cx="0" cy="0"/>
+        </a:xfrm>
+      </p:grpSpPr>
+      <p:sp>
+        <p:nvSpPr>
+          <p:cNvPr id="6" name="Rectangle 1026">
+            <a:extLst>
+              <a:ext uri="{FF2B5EF4-FFF2-40B4-BE49-F238E27FC236}">
+                <a16:creationId xmlns:a16="http://schemas.microsoft.com/office/drawing/2014/main" id="{7A22E2D8-E588-9C25-25E7-3CE6BF432045}"/>
+              </a:ext>
+            </a:extLst>
+          </p:cNvPr>
+          <p:cNvSpPr txBox="1">
+            <a:spLocks noChangeArrowheads="1"/>
+          </p:cNvSpPr>
+          <p:nvPr/>
+        </p:nvSpPr>
+        <p:spPr>
+          <a:xfrm>
+            <a:off x="2391398" y="2868119"/>
+            <a:ext cx="7409203" cy="560881"/>
+          </a:xfrm>
+          <a:prstGeom prst="rect">
+            <a:avLst/>
+          </a:prstGeom>
+        </p:spPr>
+        <p:txBody>
+          <a:bodyPr/>
+          <a:lstStyle/>
+          <a:p>
+            <a:pPr algn="ctr"/>
+            <a:r>
+              <a:rPr lang="de-AT" sz="3000" b="1">
+                <a:solidFill>
+                  <a:srgbClr val="9BBB59"/>
+                </a:solidFill>
+              </a:rPr>
+              <a:t>Vielen Dank für ihre Aufmerksamkeit</a:t>
+            </a:r>
+            <a:endParaRPr lang="de-DE" sz="3000">
+              <a:solidFill>
+                <a:srgbClr val="0070C0"/>
+              </a:solidFill>
+            </a:endParaRPr>
+          </a:p>
+        </p:txBody>
+      </p:sp>
+      <p:sp>
+        <p:nvSpPr>
+          <p:cNvPr id="7" name="Text Box 1030">
+            <a:extLst>
+              <a:ext uri="{FF2B5EF4-FFF2-40B4-BE49-F238E27FC236}">
+                <a16:creationId xmlns:a16="http://schemas.microsoft.com/office/drawing/2014/main" id="{F9901215-3C70-3A96-18D2-80145A179655}"/>
+              </a:ext>
+            </a:extLst>
+          </p:cNvPr>
+          <p:cNvSpPr txBox="1">
+            <a:spLocks noChangeArrowheads="1"/>
+          </p:cNvSpPr>
+          <p:nvPr/>
+        </p:nvSpPr>
+        <p:spPr bwMode="auto">
+          <a:xfrm>
+            <a:off x="5159826" y="4049370"/>
+            <a:ext cx="1872343" cy="1015663"/>
+          </a:xfrm>
+          <a:prstGeom prst="rect">
+            <a:avLst/>
+          </a:prstGeom>
+          <a:noFill/>
+          <a:ln w="9525">
+            <a:noFill/>
+            <a:miter lim="800000"/>
+            <a:headEnd/>
+            <a:tailEnd/>
+          </a:ln>
+        </p:spPr>
+        <p:txBody>
+          <a:bodyPr wrap="square" rIns="54000">
+            <a:spAutoFit/>
+          </a:bodyPr>
+          <a:lstStyle/>
+          <a:p>
+            <a:r>
+              <a:rPr lang="nl-NL" sz="2000"/>
+              <a:t>Michael Hänsler</a:t>
+            </a:r>
+          </a:p>
+          <a:p>
+            <a:r>
+              <a:rPr lang="nl-NL" sz="2000"/>
+              <a:t>Simon Moser</a:t>
+            </a:r>
+          </a:p>
+          <a:p>
+            <a:r>
+              <a:rPr lang="nl-NL" sz="2000"/>
+              <a:t>Lukas Fellegger</a:t>
+            </a:r>
+          </a:p>
+        </p:txBody>
+      </p:sp>
+      <p:sp>
+        <p:nvSpPr>
+          <p:cNvPr id="8" name="Text Box 1030">
+            <a:extLst>
+              <a:ext uri="{FF2B5EF4-FFF2-40B4-BE49-F238E27FC236}">
+                <a16:creationId xmlns:a16="http://schemas.microsoft.com/office/drawing/2014/main" id="{7B5E66C1-AEAA-FEA7-395D-66285D579F8F}"/>
+              </a:ext>
+            </a:extLst>
+          </p:cNvPr>
+          <p:cNvSpPr txBox="1">
+            <a:spLocks noChangeArrowheads="1"/>
+          </p:cNvSpPr>
+          <p:nvPr/>
+        </p:nvSpPr>
+        <p:spPr bwMode="auto">
+          <a:xfrm>
+            <a:off x="5177244" y="6314904"/>
+            <a:ext cx="1837509" cy="369332"/>
+          </a:xfrm>
+          <a:prstGeom prst="rect">
+            <a:avLst/>
+          </a:prstGeom>
+          <a:noFill/>
+          <a:ln w="9525">
+            <a:noFill/>
+            <a:miter lim="800000"/>
+            <a:headEnd/>
+            <a:tailEnd/>
+          </a:ln>
+        </p:spPr>
+        <p:txBody>
+          <a:bodyPr wrap="square" lIns="91440" tIns="45720" rIns="54000" bIns="45720" anchor="t">
+            <a:spAutoFit/>
+          </a:bodyPr>
+          <a:lstStyle/>
+          <a:p>
+            <a:r>
+              <a:rPr lang="de-AT"/>
+              <a:t>Stand: 26.02.2026</a:t>
+            </a:r>
+          </a:p>
+        </p:txBody>
+      </p:sp>
+      <p:sp>
+        <p:nvSpPr>
+          <p:cNvPr id="5" name="Text Box 1030">
+            <a:extLst>
+              <a:ext uri="{FF2B5EF4-FFF2-40B4-BE49-F238E27FC236}">
+                <a16:creationId xmlns:a16="http://schemas.microsoft.com/office/drawing/2014/main" id="{53066329-D502-D77A-238D-8E6D8736BC60}"/>
+              </a:ext>
+            </a:extLst>
+          </p:cNvPr>
+          <p:cNvSpPr txBox="1">
+            <a:spLocks noChangeArrowheads="1"/>
+          </p:cNvSpPr>
+          <p:nvPr/>
+        </p:nvSpPr>
+        <p:spPr bwMode="auto">
+          <a:xfrm>
+            <a:off x="4589380" y="5400124"/>
+            <a:ext cx="3013236" cy="646331"/>
+          </a:xfrm>
+          <a:prstGeom prst="rect">
+            <a:avLst/>
+          </a:prstGeom>
+          <a:noFill/>
+          <a:ln w="9525">
+            <a:noFill/>
+            <a:miter lim="800000"/>
+            <a:headEnd/>
+            <a:tailEnd/>
+          </a:ln>
+        </p:spPr>
+        <p:txBody>
+          <a:bodyPr wrap="square" lIns="91440" tIns="45720" rIns="54000" bIns="45720" anchor="t">
+            <a:spAutoFit/>
+          </a:bodyPr>
+          <a:lstStyle>
+            <a:defPPr>
+              <a:defRPr lang="de-DE"/>
+            </a:defPPr>
+            <a:lvl1pPr marL="0" algn="l" defTabSz="914400" rtl="0" eaLnBrk="1" latinLnBrk="0" hangingPunct="1">
+              <a:defRPr sz="1800" kern="1200">
+                <a:solidFill>
+                  <a:schemeClr val="tx1"/>
+                </a:solidFill>
+                <a:latin typeface="+mn-lt"/>
+                <a:ea typeface="+mn-ea"/>
+                <a:cs typeface="+mn-cs"/>
+              </a:defRPr>
+            </a:lvl1pPr>
+            <a:lvl2pPr marL="457200" algn="l" defTabSz="914400" rtl="0" eaLnBrk="1" latinLnBrk="0" hangingPunct="1">
+              <a:defRPr sz="1800" kern="1200">
+                <a:solidFill>
+                  <a:schemeClr val="tx1"/>
+                </a:solidFill>
+                <a:latin typeface="+mn-lt"/>
+                <a:ea typeface="+mn-ea"/>
+                <a:cs typeface="+mn-cs"/>
+              </a:defRPr>
+            </a:lvl2pPr>
+            <a:lvl3pPr marL="914400" algn="l" defTabSz="914400" rtl="0" eaLnBrk="1" latinLnBrk="0" hangingPunct="1">
+              <a:defRPr sz="1800" kern="1200">
+                <a:solidFill>
+                  <a:schemeClr val="tx1"/>
+                </a:solidFill>
+                <a:latin typeface="+mn-lt"/>
+                <a:ea typeface="+mn-ea"/>
+                <a:cs typeface="+mn-cs"/>
+              </a:defRPr>
+            </a:lvl3pPr>
+            <a:lvl4pPr marL="1371600" algn="l" defTabSz="914400" rtl="0" eaLnBrk="1" latinLnBrk="0" hangingPunct="1">
+              <a:defRPr sz="1800" kern="1200">
+                <a:solidFill>
+                  <a:schemeClr val="tx1"/>
+                </a:solidFill>
+                <a:latin typeface="+mn-lt"/>
+                <a:ea typeface="+mn-ea"/>
+                <a:cs typeface="+mn-cs"/>
+              </a:defRPr>
+            </a:lvl4pPr>
+            <a:lvl5pPr marL="1828800" algn="l" defTabSz="914400" rtl="0" eaLnBrk="1" latinLnBrk="0" hangingPunct="1">
+              <a:defRPr sz="1800" kern="1200">
+                <a:solidFill>
+                  <a:schemeClr val="tx1"/>
+                </a:solidFill>
+                <a:latin typeface="+mn-lt"/>
+                <a:ea typeface="+mn-ea"/>
+                <a:cs typeface="+mn-cs"/>
+              </a:defRPr>
+            </a:lvl5pPr>
+            <a:lvl6pPr marL="2286000" algn="l" defTabSz="914400" rtl="0" eaLnBrk="1" latinLnBrk="0" hangingPunct="1">
+              <a:defRPr sz="1800" kern="1200">
+                <a:solidFill>
+                  <a:schemeClr val="tx1"/>
+                </a:solidFill>
+                <a:latin typeface="+mn-lt"/>
+                <a:ea typeface="+mn-ea"/>
+                <a:cs typeface="+mn-cs"/>
+              </a:defRPr>
+            </a:lvl6pPr>
+            <a:lvl7pPr marL="2743200" algn="l" defTabSz="914400" rtl="0" eaLnBrk="1" latinLnBrk="0" hangingPunct="1">
+              <a:defRPr sz="1800" kern="1200">
+                <a:solidFill>
+                  <a:schemeClr val="tx1"/>
+                </a:solidFill>
+                <a:latin typeface="+mn-lt"/>
+                <a:ea typeface="+mn-ea"/>
+                <a:cs typeface="+mn-cs"/>
+              </a:defRPr>
+            </a:lvl7pPr>
+            <a:lvl8pPr marL="3200400" algn="l" defTabSz="914400" rtl="0" eaLnBrk="1" latinLnBrk="0" hangingPunct="1">
+              <a:defRPr sz="1800" kern="1200">
+                <a:solidFill>
+                  <a:schemeClr val="tx1"/>
+                </a:solidFill>
+                <a:latin typeface="+mn-lt"/>
+                <a:ea typeface="+mn-ea"/>
+                <a:cs typeface="+mn-cs"/>
+              </a:defRPr>
+            </a:lvl8pPr>
+            <a:lvl9pPr marL="3657600" algn="l" defTabSz="914400" rtl="0" eaLnBrk="1" latinLnBrk="0" hangingPunct="1">
+              <a:defRPr sz="1800" kern="1200">
+                <a:solidFill>
+                  <a:schemeClr val="tx1"/>
+                </a:solidFill>
+                <a:latin typeface="+mn-lt"/>
+                <a:ea typeface="+mn-ea"/>
+                <a:cs typeface="+mn-cs"/>
+              </a:defRPr>
+            </a:lvl9pPr>
+          </a:lstStyle>
+          <a:p>
+            <a:pPr algn="r"/>
+            <a:r>
+              <a:rPr lang="de-AT"/>
+              <a:t>Betreuer: Markus Zacharias</a:t>
+            </a:r>
+          </a:p>
+          <a:p>
+            <a:pPr algn="r"/>
+            <a:r>
+              <a:rPr lang="de-AT">
+                <a:ea typeface="Calibri"/>
+                <a:cs typeface="Calibri"/>
+              </a:rPr>
+              <a:t>Firmenpartner: HTL Leoben</a:t>
+            </a:r>
+          </a:p>
+        </p:txBody>
+      </p:sp>
+    </p:spTree>
+    <p:extLst>
+      <p:ext uri="{BB962C8B-B14F-4D97-AF65-F5344CB8AC3E}">
+        <p14:creationId xmlns:p14="http://schemas.microsoft.com/office/powerpoint/2010/main" val="1719908370"/>
+      </p:ext>
+    </p:extLst>
+  </p:cSld>
+  <p:clrMapOvr>
+    <a:masterClrMapping/>
+  </p:clrMapOvr>
+</p:sld>
+</file>
+
 <file path=ppt/slides/slide2.xml><?xml version="1.0" encoding="utf-8"?>
 <p:sld xmlns:a="http://schemas.openxmlformats.org/drawingml/2006/main" xmlns:r="http://schemas.openxmlformats.org/officeDocument/2006/relationships" xmlns:p="http://schemas.openxmlformats.org/presentationml/2006/main">
   <p:cSld>
@@ -4066,6 +5264,13 @@
             <a:pPr lvl="2"/>
             <a:r>
               <a:rPr lang="de-AT"/>
+              <a:t>Projektmanagement</a:t>
+            </a:r>
+          </a:p>
+          <a:p>
+            <a:pPr lvl="2"/>
+            <a:r>
+              <a:rPr lang="de-AT"/>
               <a:t>Recherche über bestehende Systeme </a:t>
             </a:r>
           </a:p>
@@ -4080,7 +5285,11 @@
             <a:pPr lvl="2"/>
             <a:r>
               <a:rPr lang="de-AT"/>
-              <a:t>Docker Deployment</a:t>
+              <a:t>Docker </a:t>
+            </a:r>
+            <a:r>
+              <a:rPr lang="de-AT" err="1"/>
+              <a:t>Deployment</a:t>
             </a:r>
             <a:endParaRPr lang="de-DE"/>
           </a:p>
@@ -4095,7 +5304,15 @@
             <a:pPr lvl="2"/>
             <a:r>
               <a:rPr lang="de-DE"/>
-              <a:t>Aufbau des Backends über REST-API </a:t>
+              <a:t>Aufbau des </a:t>
+            </a:r>
+            <a:r>
+              <a:rPr lang="de-DE" err="1"/>
+              <a:t>Backends</a:t>
+            </a:r>
+            <a:r>
+              <a:rPr lang="de-DE"/>
+              <a:t> über REST-API </a:t>
             </a:r>
           </a:p>
           <a:p>
@@ -6623,13 +7840,7 @@
   <p:cSld>
     <p:spTree>
       <p:nvGrpSpPr>
-        <p:cNvPr id="1" name="">
-          <a:extLst>
-            <a:ext uri="{FF2B5EF4-FFF2-40B4-BE49-F238E27FC236}">
-              <a16:creationId xmlns:a16="http://schemas.microsoft.com/office/drawing/2014/main" id="{ADB34A0D-25D2-379C-0144-173ABC38F681}"/>
-            </a:ext>
-          </a:extLst>
-        </p:cNvPr>
+        <p:cNvPr id="1" name=""/>
         <p:cNvGrpSpPr/>
         <p:nvPr/>
       </p:nvGrpSpPr>
@@ -6646,7 +7857,7 @@
           <p:cNvPr id="2" name="Titel 1">
             <a:extLst>
               <a:ext uri="{FF2B5EF4-FFF2-40B4-BE49-F238E27FC236}">
-                <a16:creationId xmlns:a16="http://schemas.microsoft.com/office/drawing/2014/main" id="{7EF54C98-63B2-84F6-11F8-B5AAEB9CEF46}"/>
+                <a16:creationId xmlns:a16="http://schemas.microsoft.com/office/drawing/2014/main" id="{237D006D-D692-5219-93D0-7267E5A087A5}"/>
               </a:ext>
             </a:extLst>
           </p:cNvPr>
@@ -6663,19 +7874,56 @@
           <a:lstStyle/>
           <a:p>
             <a:r>
-              <a:rPr lang="de-AT"/>
-              <a:t>Vorstellung</a:t>
-            </a:r>
-            <a:endParaRPr lang="de-DE"/>
+              <a:rPr lang="de-DE"/>
+              <a:t>Ergebnisse - Hänsler </a:t>
+            </a:r>
           </a:p>
         </p:txBody>
       </p:sp>
+      <p:pic>
+        <p:nvPicPr>
+          <p:cNvPr id="7" name="Inhaltsplatzhalter 6" descr="Ein Bild, das Screenshot, Text, Software, Multimedia-Software enthält.&#10;&#10;KI-generierte Inhalte können fehlerhaft sein.">
+            <a:extLst>
+              <a:ext uri="{FF2B5EF4-FFF2-40B4-BE49-F238E27FC236}">
+                <a16:creationId xmlns:a16="http://schemas.microsoft.com/office/drawing/2014/main" id="{639AE848-D40D-F017-CC2B-057078A36156}"/>
+              </a:ext>
+            </a:extLst>
+          </p:cNvPr>
+          <p:cNvPicPr>
+            <a:picLocks noGrp="1" noChangeAspect="1"/>
+          </p:cNvPicPr>
+          <p:nvPr>
+            <p:ph idx="1"/>
+          </p:nvPr>
+        </p:nvPicPr>
+        <p:blipFill>
+          <a:blip r:embed="rId2">
+            <a:extLst>
+              <a:ext uri="{28A0092B-C50C-407E-A947-70E740481C1C}">
+                <a14:useLocalDpi xmlns:a14="http://schemas.microsoft.com/office/drawing/2010/main" val="0"/>
+              </a:ext>
+            </a:extLst>
+          </a:blip>
+          <a:stretch>
+            <a:fillRect/>
+          </a:stretch>
+        </p:blipFill>
+        <p:spPr>
+          <a:xfrm>
+            <a:off x="5766193" y="1095711"/>
+            <a:ext cx="6226007" cy="5073650"/>
+          </a:xfrm>
+          <a:prstGeom prst="rect">
+            <a:avLst/>
+          </a:prstGeom>
+        </p:spPr>
+      </p:pic>
       <p:sp>
         <p:nvSpPr>
           <p:cNvPr id="4" name="Fußzeilenplatzhalter 3">
             <a:extLst>
               <a:ext uri="{FF2B5EF4-FFF2-40B4-BE49-F238E27FC236}">
-                <a16:creationId xmlns:a16="http://schemas.microsoft.com/office/drawing/2014/main" id="{F6D1FB5E-98BA-EEF5-C10F-DFB50DE2966D}"/>
+                <a16:creationId xmlns:a16="http://schemas.microsoft.com/office/drawing/2014/main" id="{0D69777C-0275-D8F0-8251-D1C5092589C0}"/>
               </a:ext>
             </a:extLst>
           </p:cNvPr>
@@ -6693,7 +7941,7 @@
           <a:p>
             <a:r>
               <a:rPr lang="de-AT"/>
-              <a:t>Infopoint – Hänsler – Moser – Fellegger</a:t>
+              <a:t>Infopoint – Hänsler – Moser – Fellegger </a:t>
             </a:r>
           </a:p>
         </p:txBody>
@@ -6703,7 +7951,7 @@
           <p:cNvPr id="5" name="Foliennummernplatzhalter 4">
             <a:extLst>
               <a:ext uri="{FF2B5EF4-FFF2-40B4-BE49-F238E27FC236}">
-                <a16:creationId xmlns:a16="http://schemas.microsoft.com/office/drawing/2014/main" id="{46080CEB-0ECE-A4EA-50E4-D85A98DFFEA6}"/>
+                <a16:creationId xmlns:a16="http://schemas.microsoft.com/office/drawing/2014/main" id="{A3B1741B-5CCC-AABB-C793-DB7458BC6479}"/>
               </a:ext>
             </a:extLst>
           </p:cNvPr>
@@ -6728,62 +7976,46 @@
           </a:p>
         </p:txBody>
       </p:sp>
-      <p:sp>
-        <p:nvSpPr>
-          <p:cNvPr id="8" name="Rectangle 1026">
+      <p:pic>
+        <p:nvPicPr>
+          <p:cNvPr id="9" name="Grafik 8" descr="Ein Bild, das Screenshot, Text, Design enthält.&#10;&#10;KI-generierte Inhalte können fehlerhaft sein.">
             <a:extLst>
               <a:ext uri="{FF2B5EF4-FFF2-40B4-BE49-F238E27FC236}">
-                <a16:creationId xmlns:a16="http://schemas.microsoft.com/office/drawing/2014/main" id="{8F4A3BFE-458C-A17D-5B6D-84768E53AEA3}"/>
+                <a16:creationId xmlns:a16="http://schemas.microsoft.com/office/drawing/2014/main" id="{82A5C20B-BC4E-6111-8EF3-2B7845E12E0E}"/>
               </a:ext>
             </a:extLst>
           </p:cNvPr>
-          <p:cNvSpPr txBox="1">
-            <a:spLocks noChangeArrowheads="1"/>
-          </p:cNvSpPr>
+          <p:cNvPicPr>
+            <a:picLocks noChangeAspect="1"/>
+          </p:cNvPicPr>
           <p:nvPr/>
-        </p:nvSpPr>
+        </p:nvPicPr>
+        <p:blipFill>
+          <a:blip r:embed="rId3">
+            <a:extLst>
+              <a:ext uri="{28A0092B-C50C-407E-A947-70E740481C1C}">
+                <a14:useLocalDpi xmlns:a14="http://schemas.microsoft.com/office/drawing/2010/main" val="0"/>
+              </a:ext>
+            </a:extLst>
+          </a:blip>
+          <a:stretch>
+            <a:fillRect/>
+          </a:stretch>
+        </p:blipFill>
         <p:spPr>
           <a:xfrm>
-            <a:off x="4769562" y="2878558"/>
-            <a:ext cx="2652875" cy="550442"/>
+            <a:off x="199799" y="1095711"/>
+            <a:ext cx="5491699" cy="5073650"/>
           </a:xfrm>
           <a:prstGeom prst="rect">
             <a:avLst/>
           </a:prstGeom>
         </p:spPr>
-        <p:txBody>
-          <a:bodyPr/>
-          <a:lstStyle/>
-          <a:p>
-            <a:pPr algn="ctr"/>
-            <a:r>
-              <a:rPr lang="de-AT" sz="4400" b="1">
-                <a:solidFill>
-                  <a:srgbClr val="9BBB59"/>
-                </a:solidFill>
-              </a:rPr>
-              <a:t>Live Demo</a:t>
-            </a:r>
-          </a:p>
-          <a:p>
-            <a:pPr lvl="0" algn="ctr">
-              <a:spcBef>
-                <a:spcPct val="0"/>
-              </a:spcBef>
-              <a:defRPr/>
-            </a:pPr>
-            <a:endParaRPr lang="de-DE" sz="4400">
-              <a:solidFill>
-                <a:srgbClr val="0070C0"/>
-              </a:solidFill>
-            </a:endParaRPr>
-          </a:p>
-        </p:txBody>
-      </p:sp>
+      </p:pic>
     </p:spTree>
     <p:extLst>
       <p:ext uri="{BB962C8B-B14F-4D97-AF65-F5344CB8AC3E}">
-        <p14:creationId xmlns:p14="http://schemas.microsoft.com/office/powerpoint/2010/main" val="219802421"/>
+        <p14:creationId xmlns:p14="http://schemas.microsoft.com/office/powerpoint/2010/main" val="3186464633"/>
       </p:ext>
     </p:extLst>
   </p:cSld>
@@ -6815,7 +8047,7 @@
           <p:cNvPr id="2" name="Titel 1">
             <a:extLst>
               <a:ext uri="{FF2B5EF4-FFF2-40B4-BE49-F238E27FC236}">
-                <a16:creationId xmlns:a16="http://schemas.microsoft.com/office/drawing/2014/main" id="{E496C6BA-99A1-43F4-92B8-B6D762EF0987}"/>
+                <a16:creationId xmlns:a16="http://schemas.microsoft.com/office/drawing/2014/main" id="{257528A1-5242-0F4F-4EC6-661C73DF1412}"/>
               </a:ext>
             </a:extLst>
           </p:cNvPr>
@@ -6833,243 +8065,55 @@
           <a:p>
             <a:r>
               <a:rPr lang="de-DE"/>
-              <a:t>Literatur</a:t>
-            </a:r>
-            <a:endParaRPr lang="de-AT"/>
+              <a:t>Ergebnisse - Hänsler </a:t>
+            </a:r>
           </a:p>
         </p:txBody>
       </p:sp>
-      <p:sp>
-        <p:nvSpPr>
-          <p:cNvPr id="3" name="Inhaltsplatzhalter 2">
+      <p:pic>
+        <p:nvPicPr>
+          <p:cNvPr id="7" name="Inhaltsplatzhalter 6" descr="Ein Bild, das Text, Screenshot, Software, Multimedia-Software enthält.&#10;&#10;KI-generierte Inhalte können fehlerhaft sein.">
             <a:extLst>
               <a:ext uri="{FF2B5EF4-FFF2-40B4-BE49-F238E27FC236}">
-                <a16:creationId xmlns:a16="http://schemas.microsoft.com/office/drawing/2014/main" id="{A228378C-21E0-453B-B255-71BAC911E6C0}"/>
+                <a16:creationId xmlns:a16="http://schemas.microsoft.com/office/drawing/2014/main" id="{2A9EB6FD-91D3-1D58-983F-30F43FD4CA2E}"/>
               </a:ext>
             </a:extLst>
           </p:cNvPr>
-          <p:cNvSpPr>
-            <a:spLocks noGrp="1"/>
-          </p:cNvSpPr>
+          <p:cNvPicPr>
+            <a:picLocks noGrp="1" noChangeAspect="1"/>
+          </p:cNvPicPr>
           <p:nvPr>
             <p:ph idx="1"/>
           </p:nvPr>
-        </p:nvSpPr>
+        </p:nvPicPr>
+        <p:blipFill>
+          <a:blip r:embed="rId2">
+            <a:extLst>
+              <a:ext uri="{28A0092B-C50C-407E-A947-70E740481C1C}">
+                <a14:useLocalDpi xmlns:a14="http://schemas.microsoft.com/office/drawing/2010/main" val="0"/>
+              </a:ext>
+            </a:extLst>
+          </a:blip>
+          <a:stretch>
+            <a:fillRect/>
+          </a:stretch>
+        </p:blipFill>
         <p:spPr>
           <a:xfrm>
-            <a:off x="609600" y="1166069"/>
-            <a:ext cx="10972800" cy="4748169"/>
+            <a:off x="4536053" y="1095711"/>
+            <a:ext cx="7590429" cy="5073650"/>
           </a:xfrm>
+          <a:prstGeom prst="rect">
+            <a:avLst/>
+          </a:prstGeom>
         </p:spPr>
-        <p:txBody>
-          <a:bodyPr vert="horz" lIns="91440" tIns="45720" rIns="91440" bIns="45720" rtlCol="0" anchor="t">
-            <a:normAutofit fontScale="85000" lnSpcReduction="20000"/>
-          </a:bodyPr>
-          <a:lstStyle/>
-          <a:p>
-            <a:pPr>
-              <a:lnSpc>
-                <a:spcPct val="120000"/>
-              </a:lnSpc>
-            </a:pPr>
-            <a:r>
-              <a:rPr lang="de-DE"/>
-              <a:t>Bis dato durchgesehen:</a:t>
-            </a:r>
-            <a:endParaRPr lang="de-AT"/>
-          </a:p>
-          <a:p>
-            <a:pPr lvl="1">
-              <a:lnSpc>
-                <a:spcPct val="120000"/>
-              </a:lnSpc>
-            </a:pPr>
-            <a:r>
-              <a:rPr lang="de-DE">
-                <a:hlinkClick r:id="rId2">
-                  <a:extLst>
-                    <a:ext uri="{A12FA001-AC4F-418D-AE19-62706E023703}">
-                      <ahyp:hlinkClr xmlns:ahyp="http://schemas.microsoft.com/office/drawing/2018/hyperlinkcolor" val="tx"/>
-                    </a:ext>
-                  </a:extLst>
-                </a:hlinkClick>
-              </a:rPr>
-              <a:t>https://epub.uni-regensburg.de/10868/1/Knowledge_Management_und_Kommunikationssysteme.pdf#page=137</a:t>
-            </a:r>
-            <a:r>
-              <a:rPr lang="de-DE"/>
-              <a:t> </a:t>
-            </a:r>
-          </a:p>
-          <a:p>
-            <a:pPr lvl="1">
-              <a:lnSpc>
-                <a:spcPct val="120000"/>
-              </a:lnSpc>
-            </a:pPr>
-            <a:r>
-              <a:rPr lang="de-DE">
-                <a:hlinkClick r:id="rId3">
-                  <a:extLst>
-                    <a:ext uri="{A12FA001-AC4F-418D-AE19-62706E023703}">
-                      <ahyp:hlinkClr xmlns:ahyp="http://schemas.microsoft.com/office/drawing/2018/hyperlinkcolor" val="tx"/>
-                    </a:ext>
-                  </a:extLst>
-                </a:hlinkClick>
-              </a:rPr>
-              <a:t>https://infopoints.com</a:t>
-            </a:r>
-            <a:r>
-              <a:rPr lang="de-DE"/>
-              <a:t> </a:t>
-            </a:r>
-          </a:p>
-          <a:p>
-            <a:pPr lvl="1">
-              <a:lnSpc>
-                <a:spcPct val="120000"/>
-              </a:lnSpc>
-            </a:pPr>
-            <a:r>
-              <a:rPr lang="de-DE">
-                <a:hlinkClick r:id="rId4">
-                  <a:extLst>
-                    <a:ext uri="{A12FA001-AC4F-418D-AE19-62706E023703}">
-                      <ahyp:hlinkClr xmlns:ahyp="http://schemas.microsoft.com/office/drawing/2018/hyperlinkcolor" val="tx"/>
-                    </a:ext>
-                  </a:extLst>
-                </a:hlinkClick>
-              </a:rPr>
-              <a:t>https://www.eca.europa.eu/en/sustainable-development-goals</a:t>
-            </a:r>
-            <a:r>
-              <a:rPr lang="de-DE"/>
-              <a:t> </a:t>
-            </a:r>
-          </a:p>
-          <a:p>
-            <a:pPr lvl="1">
-              <a:lnSpc>
-                <a:spcPct val="120000"/>
-              </a:lnSpc>
-            </a:pPr>
-            <a:r>
-              <a:rPr lang="de-DE">
-                <a:hlinkClick r:id="rId5">
-                  <a:extLst>
-                    <a:ext uri="{A12FA001-AC4F-418D-AE19-62706E023703}">
-                      <ahyp:hlinkClr xmlns:ahyp="http://schemas.microsoft.com/office/drawing/2018/hyperlinkcolor" val="tx"/>
-                    </a:ext>
-                  </a:extLst>
-                </a:hlinkClick>
-              </a:rPr>
-              <a:t>https://helpx.adobe.com/at/xd/user-guide.html</a:t>
-            </a:r>
-            <a:endParaRPr lang="de-DE"/>
-          </a:p>
-          <a:p>
-            <a:pPr lvl="1">
-              <a:lnSpc>
-                <a:spcPct val="120000"/>
-              </a:lnSpc>
-            </a:pPr>
-            <a:r>
-              <a:rPr lang="de-DE">
-                <a:hlinkClick r:id="rId6">
-                  <a:extLst>
-                    <a:ext uri="{A12FA001-AC4F-418D-AE19-62706E023703}">
-                      <ahyp:hlinkClr xmlns:ahyp="http://schemas.microsoft.com/office/drawing/2018/hyperlinkcolor" val="tx"/>
-                    </a:ext>
-                  </a:extLst>
-                </a:hlinkClick>
-              </a:rPr>
-              <a:t>https://react.dev/reference/react</a:t>
-            </a:r>
-            <a:endParaRPr lang="de-DE"/>
-          </a:p>
-          <a:p>
-            <a:pPr lvl="1">
-              <a:lnSpc>
-                <a:spcPct val="120000"/>
-              </a:lnSpc>
-            </a:pPr>
-            <a:r>
-              <a:rPr lang="de-DE">
-                <a:hlinkClick r:id="rId7">
-                  <a:extLst>
-                    <a:ext uri="{A12FA001-AC4F-418D-AE19-62706E023703}">
-                      <ahyp:hlinkClr xmlns:ahyp="http://schemas.microsoft.com/office/drawing/2018/hyperlinkcolor" val="tx"/>
-                    </a:ext>
-                  </a:extLst>
-                </a:hlinkClick>
-              </a:rPr>
-              <a:t>https://vite.dev/guide/features</a:t>
-            </a:r>
-            <a:endParaRPr lang="de-DE"/>
-          </a:p>
-          <a:p>
-            <a:pPr lvl="1">
-              <a:lnSpc>
-                <a:spcPct val="120000"/>
-              </a:lnSpc>
-            </a:pPr>
-            <a:r>
-              <a:rPr lang="de-DE">
-                <a:hlinkClick r:id="rId8">
-                  <a:extLst>
-                    <a:ext uri="{A12FA001-AC4F-418D-AE19-62706E023703}">
-                      <ahyp:hlinkClr xmlns:ahyp="http://schemas.microsoft.com/office/drawing/2018/hyperlinkcolor" val="tx"/>
-                    </a:ext>
-                  </a:extLst>
-                </a:hlinkClick>
-              </a:rPr>
-              <a:t>https://help.untis.at/hc/de/articles/4403351094034-General-documentation-for-integration-partners</a:t>
-            </a:r>
-            <a:endParaRPr lang="de-DE"/>
-          </a:p>
-          <a:p>
-            <a:pPr lvl="1">
-              <a:lnSpc>
-                <a:spcPct val="120000"/>
-              </a:lnSpc>
-            </a:pPr>
-            <a:r>
-              <a:rPr lang="de-DE">
-                <a:hlinkClick r:id="rId9">
-                  <a:extLst>
-                    <a:ext uri="{A12FA001-AC4F-418D-AE19-62706E023703}">
-                      <ahyp:hlinkClr xmlns:ahyp="http://schemas.microsoft.com/office/drawing/2018/hyperlinkcolor" val="tx"/>
-                    </a:ext>
-                  </a:extLst>
-                </a:hlinkClick>
-              </a:rPr>
-              <a:t>https://getcockpit.com/documentation</a:t>
-            </a:r>
-            <a:endParaRPr lang="de-DE"/>
-          </a:p>
-          <a:p>
-            <a:pPr lvl="1">
-              <a:lnSpc>
-                <a:spcPct val="120000"/>
-              </a:lnSpc>
-            </a:pPr>
-            <a:r>
-              <a:rPr lang="de-DE" u="sng"/>
-              <a:t>https://docs.docker.com</a:t>
-            </a:r>
-            <a:br>
-              <a:rPr lang="de-DE"/>
-            </a:br>
-            <a:endParaRPr lang="de-DE"/>
-          </a:p>
-        </p:txBody>
-      </p:sp>
+      </p:pic>
       <p:sp>
         <p:nvSpPr>
           <p:cNvPr id="4" name="Fußzeilenplatzhalter 3">
             <a:extLst>
               <a:ext uri="{FF2B5EF4-FFF2-40B4-BE49-F238E27FC236}">
-                <a16:creationId xmlns:a16="http://schemas.microsoft.com/office/drawing/2014/main" id="{8AADA028-308D-430B-A45B-407D875A2351}"/>
+                <a16:creationId xmlns:a16="http://schemas.microsoft.com/office/drawing/2014/main" id="{97F5DC89-ABCF-0AA5-FD33-03CE9E7FE1C0}"/>
               </a:ext>
             </a:extLst>
           </p:cNvPr>
@@ -7087,7 +8131,7 @@
           <a:p>
             <a:r>
               <a:rPr lang="de-AT"/>
-              <a:t>Infopoint – Hänsler – Moser – Fellegger </a:t>
+              <a:t>Infopoint – Hänsler – Moser – Fellegger</a:t>
             </a:r>
           </a:p>
         </p:txBody>
@@ -7097,7 +8141,7 @@
           <p:cNvPr id="5" name="Foliennummernplatzhalter 4">
             <a:extLst>
               <a:ext uri="{FF2B5EF4-FFF2-40B4-BE49-F238E27FC236}">
-                <a16:creationId xmlns:a16="http://schemas.microsoft.com/office/drawing/2014/main" id="{AB38338F-922C-40A7-B140-637B827703BF}"/>
+                <a16:creationId xmlns:a16="http://schemas.microsoft.com/office/drawing/2014/main" id="{A4622F8A-C44D-D951-F58F-9C27AB231F9C}"/>
               </a:ext>
             </a:extLst>
           </p:cNvPr>
@@ -7122,10 +8166,45 @@
           </a:p>
         </p:txBody>
       </p:sp>
+      <p:sp>
+        <p:nvSpPr>
+          <p:cNvPr id="8" name="Textfeld 7">
+            <a:extLst>
+              <a:ext uri="{FF2B5EF4-FFF2-40B4-BE49-F238E27FC236}">
+                <a16:creationId xmlns:a16="http://schemas.microsoft.com/office/drawing/2014/main" id="{6A9B9D5B-DF58-3A2C-F8EB-87765A891255}"/>
+              </a:ext>
+            </a:extLst>
+          </p:cNvPr>
+          <p:cNvSpPr txBox="1"/>
+          <p:nvPr/>
+        </p:nvSpPr>
+        <p:spPr>
+          <a:xfrm>
+            <a:off x="264920" y="1095711"/>
+            <a:ext cx="4144710" cy="369332"/>
+          </a:xfrm>
+          <a:prstGeom prst="rect">
+            <a:avLst/>
+          </a:prstGeom>
+          <a:noFill/>
+        </p:spPr>
+        <p:txBody>
+          <a:bodyPr wrap="square" rtlCol="0">
+            <a:spAutoFit/>
+          </a:bodyPr>
+          <a:lstStyle/>
+          <a:p>
+            <a:r>
+              <a:rPr lang="de-DE"/>
+              <a:t>Erstmaliges bauen über </a:t>
+            </a:r>
+          </a:p>
+        </p:txBody>
+      </p:sp>
     </p:spTree>
     <p:extLst>
       <p:ext uri="{BB962C8B-B14F-4D97-AF65-F5344CB8AC3E}">
-        <p14:creationId xmlns:p14="http://schemas.microsoft.com/office/powerpoint/2010/main" val="2929837528"/>
+        <p14:creationId xmlns:p14="http://schemas.microsoft.com/office/powerpoint/2010/main" val="2285032369"/>
       </p:ext>
     </p:extLst>
   </p:cSld>
@@ -7140,13 +8219,7 @@
   <p:cSld>
     <p:spTree>
       <p:nvGrpSpPr>
-        <p:cNvPr id="1" name="">
-          <a:extLst>
-            <a:ext uri="{FF2B5EF4-FFF2-40B4-BE49-F238E27FC236}">
-              <a16:creationId xmlns:a16="http://schemas.microsoft.com/office/drawing/2014/main" id="{5F888E23-8483-4BC2-2386-C82FDAF0F799}"/>
-            </a:ext>
-          </a:extLst>
-        </p:cNvPr>
+        <p:cNvPr id="1" name=""/>
         <p:cNvGrpSpPr/>
         <p:nvPr/>
       </p:nvGrpSpPr>
@@ -7160,298 +8233,280 @@
       </p:grpSpPr>
       <p:sp>
         <p:nvSpPr>
-          <p:cNvPr id="6" name="Rectangle 1026">
+          <p:cNvPr id="2" name="Titel 1">
             <a:extLst>
               <a:ext uri="{FF2B5EF4-FFF2-40B4-BE49-F238E27FC236}">
-                <a16:creationId xmlns:a16="http://schemas.microsoft.com/office/drawing/2014/main" id="{7A22E2D8-E588-9C25-25E7-3CE6BF432045}"/>
+                <a16:creationId xmlns:a16="http://schemas.microsoft.com/office/drawing/2014/main" id="{BB3372C5-1394-0BD3-811C-922AD511BFCB}"/>
               </a:ext>
             </a:extLst>
           </p:cNvPr>
-          <p:cNvSpPr txBox="1">
-            <a:spLocks noChangeArrowheads="1"/>
+          <p:cNvSpPr>
+            <a:spLocks noGrp="1"/>
           </p:cNvSpPr>
+          <p:nvPr>
+            <p:ph type="title"/>
+          </p:nvPr>
+        </p:nvSpPr>
+        <p:spPr/>
+        <p:txBody>
+          <a:bodyPr/>
+          <a:lstStyle/>
+          <a:p>
+            <a:r>
+              <a:rPr lang="de-DE"/>
+              <a:t>Ergebnisse - Moser</a:t>
+            </a:r>
+            <a:endParaRPr lang="de-AT"/>
+          </a:p>
+        </p:txBody>
+      </p:sp>
+      <p:sp>
+        <p:nvSpPr>
+          <p:cNvPr id="3" name="Inhaltsplatzhalter 2">
+            <a:extLst>
+              <a:ext uri="{FF2B5EF4-FFF2-40B4-BE49-F238E27FC236}">
+                <a16:creationId xmlns:a16="http://schemas.microsoft.com/office/drawing/2014/main" id="{5D32C03D-333F-0455-9E0E-2FF70885CAC2}"/>
+              </a:ext>
+            </a:extLst>
+          </p:cNvPr>
+          <p:cNvSpPr>
+            <a:spLocks noGrp="1"/>
+          </p:cNvSpPr>
+          <p:nvPr>
+            <p:ph idx="1"/>
+          </p:nvPr>
+        </p:nvSpPr>
+        <p:spPr/>
+        <p:txBody>
+          <a:bodyPr vert="horz" lIns="91440" tIns="45720" rIns="91440" bIns="45720" rtlCol="0" anchor="t">
+            <a:normAutofit/>
+          </a:bodyPr>
+          <a:lstStyle/>
+          <a:p>
+            <a:pPr>
+              <a:lnSpc>
+                <a:spcPct val="250000"/>
+              </a:lnSpc>
+            </a:pPr>
+            <a:r>
+              <a:rPr lang="de-AT" sz="2400" err="1">
+                <a:ea typeface="+mn-lt"/>
+                <a:cs typeface="+mn-lt"/>
+              </a:rPr>
+              <a:t>clients</a:t>
+            </a:r>
+            <a:r>
+              <a:rPr lang="de-AT" sz="2400">
+                <a:ea typeface="+mn-lt"/>
+                <a:cs typeface="+mn-lt"/>
+              </a:rPr>
+              <a:t>/ → Zugriff auf externe APIs (CMS, </a:t>
+            </a:r>
+            <a:r>
+              <a:rPr lang="de-AT" sz="2400" err="1">
+                <a:ea typeface="+mn-lt"/>
+                <a:cs typeface="+mn-lt"/>
+              </a:rPr>
+              <a:t>Untis</a:t>
+            </a:r>
+            <a:r>
+              <a:rPr lang="de-AT" sz="2400">
+                <a:ea typeface="+mn-lt"/>
+                <a:cs typeface="+mn-lt"/>
+              </a:rPr>
+              <a:t>)</a:t>
+            </a:r>
+          </a:p>
+          <a:p>
+            <a:pPr>
+              <a:lnSpc>
+                <a:spcPct val="250000"/>
+              </a:lnSpc>
+            </a:pPr>
+            <a:r>
+              <a:rPr lang="de-AT" sz="2400" err="1">
+                <a:ea typeface="+mn-lt"/>
+                <a:cs typeface="+mn-lt"/>
+              </a:rPr>
+              <a:t>controller</a:t>
+            </a:r>
+            <a:r>
+              <a:rPr lang="de-AT" sz="2400">
+                <a:ea typeface="+mn-lt"/>
+                <a:cs typeface="+mn-lt"/>
+              </a:rPr>
+              <a:t>/ → REST-Endpunkte</a:t>
+            </a:r>
+          </a:p>
+          <a:p>
+            <a:pPr>
+              <a:lnSpc>
+                <a:spcPct val="250000"/>
+              </a:lnSpc>
+            </a:pPr>
+            <a:r>
+              <a:rPr lang="de-AT" sz="2400" err="1">
+                <a:ea typeface="+mn-lt"/>
+                <a:cs typeface="+mn-lt"/>
+              </a:rPr>
+              <a:t>service</a:t>
+            </a:r>
+            <a:r>
+              <a:rPr lang="de-AT" sz="2400">
+                <a:ea typeface="+mn-lt"/>
+                <a:cs typeface="+mn-lt"/>
+              </a:rPr>
+              <a:t>/ → Geschäftslogik</a:t>
+            </a:r>
+          </a:p>
+          <a:p>
+            <a:pPr>
+              <a:lnSpc>
+                <a:spcPct val="250000"/>
+              </a:lnSpc>
+            </a:pPr>
+            <a:r>
+              <a:rPr lang="de-AT" sz="2400" err="1">
+                <a:ea typeface="+mn-lt"/>
+                <a:cs typeface="+mn-lt"/>
+              </a:rPr>
+              <a:t>dto</a:t>
+            </a:r>
+            <a:r>
+              <a:rPr lang="de-AT" sz="2400">
+                <a:ea typeface="+mn-lt"/>
+                <a:cs typeface="+mn-lt"/>
+              </a:rPr>
+              <a:t>/ → API-Modelle</a:t>
+            </a:r>
+          </a:p>
+          <a:p>
+            <a:pPr>
+              <a:lnSpc>
+                <a:spcPct val="250000"/>
+              </a:lnSpc>
+            </a:pPr>
+            <a:r>
+              <a:rPr lang="de-AT" sz="2400" err="1">
+                <a:ea typeface="+mn-lt"/>
+                <a:cs typeface="+mn-lt"/>
+              </a:rPr>
+              <a:t>util</a:t>
+            </a:r>
+            <a:r>
+              <a:rPr lang="de-AT" sz="2400">
+                <a:ea typeface="+mn-lt"/>
+                <a:cs typeface="+mn-lt"/>
+              </a:rPr>
+              <a:t>/ → Hilfsfunktionen</a:t>
+            </a:r>
+            <a:endParaRPr lang="de-AT" sz="2400">
+              <a:ea typeface="Calibri"/>
+              <a:cs typeface="Calibri"/>
+            </a:endParaRPr>
+          </a:p>
+        </p:txBody>
+      </p:sp>
+      <p:sp>
+        <p:nvSpPr>
+          <p:cNvPr id="4" name="Fußzeilenplatzhalter 3">
+            <a:extLst>
+              <a:ext uri="{FF2B5EF4-FFF2-40B4-BE49-F238E27FC236}">
+                <a16:creationId xmlns:a16="http://schemas.microsoft.com/office/drawing/2014/main" id="{0D66EDCA-6C1F-74B5-60B4-D35DDFCC3F5B}"/>
+              </a:ext>
+            </a:extLst>
+          </p:cNvPr>
+          <p:cNvSpPr>
+            <a:spLocks noGrp="1"/>
+          </p:cNvSpPr>
+          <p:nvPr>
+            <p:ph type="ftr" sz="quarter" idx="11"/>
+          </p:nvPr>
+        </p:nvSpPr>
+        <p:spPr/>
+        <p:txBody>
+          <a:bodyPr/>
+          <a:lstStyle/>
+          <a:p>
+            <a:r>
+              <a:rPr lang="de-AT"/>
+              <a:t>Infopoint – </a:t>
+            </a:r>
+            <a:r>
+              <a:rPr lang="de-AT" err="1"/>
+              <a:t>Hänsler</a:t>
+            </a:r>
+            <a:r>
+              <a:rPr lang="de-AT"/>
+              <a:t> – Moser – Fellegger </a:t>
+            </a:r>
+          </a:p>
+        </p:txBody>
+      </p:sp>
+      <p:sp>
+        <p:nvSpPr>
+          <p:cNvPr id="5" name="Foliennummernplatzhalter 4">
+            <a:extLst>
+              <a:ext uri="{FF2B5EF4-FFF2-40B4-BE49-F238E27FC236}">
+                <a16:creationId xmlns:a16="http://schemas.microsoft.com/office/drawing/2014/main" id="{40EFB219-AE08-0469-8A31-D472EA25154E}"/>
+              </a:ext>
+            </a:extLst>
+          </p:cNvPr>
+          <p:cNvSpPr>
+            <a:spLocks noGrp="1"/>
+          </p:cNvSpPr>
+          <p:nvPr>
+            <p:ph type="sldNum" sz="quarter" idx="12"/>
+          </p:nvPr>
+        </p:nvSpPr>
+        <p:spPr/>
+        <p:txBody>
+          <a:bodyPr/>
+          <a:lstStyle/>
+          <a:p>
+            <a:fld id="{7DCD6803-3BAA-44F6-A698-23D950C9713B}" type="slidenum">
+              <a:rPr lang="de-AT" smtClean="0"/>
+              <a:pPr/>
+              <a:t>9</a:t>
+            </a:fld>
+            <a:endParaRPr lang="de-AT"/>
+          </a:p>
+        </p:txBody>
+      </p:sp>
+      <p:pic>
+        <p:nvPicPr>
+          <p:cNvPr id="7" name="Grafik 6" descr="Ein Bild, das Text, Screenshot, Schrift, Dokument enthält.&#10;&#10;KI-generierte Inhalte können fehlerhaft sein.">
+            <a:extLst>
+              <a:ext uri="{FF2B5EF4-FFF2-40B4-BE49-F238E27FC236}">
+                <a16:creationId xmlns:a16="http://schemas.microsoft.com/office/drawing/2014/main" id="{50CE2C5C-45A5-022F-D59C-34F5C245C10F}"/>
+              </a:ext>
+            </a:extLst>
+          </p:cNvPr>
+          <p:cNvPicPr>
+            <a:picLocks noChangeAspect="1"/>
+          </p:cNvPicPr>
           <p:nvPr/>
-        </p:nvSpPr>
+        </p:nvPicPr>
+        <p:blipFill>
+          <a:blip r:embed="rId2"/>
+          <a:stretch>
+            <a:fillRect/>
+          </a:stretch>
+        </p:blipFill>
         <p:spPr>
           <a:xfrm>
-            <a:off x="2391398" y="2868119"/>
-            <a:ext cx="7409203" cy="560881"/>
+            <a:off x="8548514" y="1057138"/>
+            <a:ext cx="3226543" cy="5068958"/>
           </a:xfrm>
           <a:prstGeom prst="rect">
             <a:avLst/>
           </a:prstGeom>
         </p:spPr>
-        <p:txBody>
-          <a:bodyPr/>
-          <a:lstStyle/>
-          <a:p>
-            <a:pPr algn="ctr"/>
-            <a:r>
-              <a:rPr lang="de-AT" sz="3000" b="1">
-                <a:solidFill>
-                  <a:srgbClr val="9BBB59"/>
-                </a:solidFill>
-              </a:rPr>
-              <a:t>Vielen Dank für ihre Aufmerksamkeit</a:t>
-            </a:r>
-            <a:endParaRPr lang="de-DE" sz="3000">
-              <a:solidFill>
-                <a:srgbClr val="0070C0"/>
-              </a:solidFill>
-            </a:endParaRPr>
-          </a:p>
-        </p:txBody>
-      </p:sp>
-      <p:sp>
-        <p:nvSpPr>
-          <p:cNvPr id="7" name="Text Box 1030">
-            <a:extLst>
-              <a:ext uri="{FF2B5EF4-FFF2-40B4-BE49-F238E27FC236}">
-                <a16:creationId xmlns:a16="http://schemas.microsoft.com/office/drawing/2014/main" id="{F9901215-3C70-3A96-18D2-80145A179655}"/>
-              </a:ext>
-            </a:extLst>
-          </p:cNvPr>
-          <p:cNvSpPr txBox="1">
-            <a:spLocks noChangeArrowheads="1"/>
-          </p:cNvSpPr>
-          <p:nvPr/>
-        </p:nvSpPr>
-        <p:spPr bwMode="auto">
-          <a:xfrm>
-            <a:off x="5159826" y="4049370"/>
-            <a:ext cx="1872343" cy="1015663"/>
-          </a:xfrm>
-          <a:prstGeom prst="rect">
-            <a:avLst/>
-          </a:prstGeom>
-          <a:noFill/>
-          <a:ln w="9525">
-            <a:noFill/>
-            <a:miter lim="800000"/>
-            <a:headEnd/>
-            <a:tailEnd/>
-          </a:ln>
-        </p:spPr>
-        <p:txBody>
-          <a:bodyPr wrap="square" rIns="54000">
-            <a:spAutoFit/>
-          </a:bodyPr>
-          <a:lstStyle/>
-          <a:p>
-            <a:r>
-              <a:rPr lang="nl-NL" sz="2000"/>
-              <a:t>Michael Hänsler</a:t>
-            </a:r>
-          </a:p>
-          <a:p>
-            <a:r>
-              <a:rPr lang="nl-NL" sz="2000"/>
-              <a:t>Simon Moser</a:t>
-            </a:r>
-          </a:p>
-          <a:p>
-            <a:r>
-              <a:rPr lang="nl-NL" sz="2000"/>
-              <a:t>Lukas Fellegger</a:t>
-            </a:r>
-          </a:p>
-        </p:txBody>
-      </p:sp>
-      <p:sp>
-        <p:nvSpPr>
-          <p:cNvPr id="8" name="Text Box 1030">
-            <a:extLst>
-              <a:ext uri="{FF2B5EF4-FFF2-40B4-BE49-F238E27FC236}">
-                <a16:creationId xmlns:a16="http://schemas.microsoft.com/office/drawing/2014/main" id="{7B5E66C1-AEAA-FEA7-395D-66285D579F8F}"/>
-              </a:ext>
-            </a:extLst>
-          </p:cNvPr>
-          <p:cNvSpPr txBox="1">
-            <a:spLocks noChangeArrowheads="1"/>
-          </p:cNvSpPr>
-          <p:nvPr/>
-        </p:nvSpPr>
-        <p:spPr bwMode="auto">
-          <a:xfrm>
-            <a:off x="5177244" y="6314904"/>
-            <a:ext cx="1837509" cy="369332"/>
-          </a:xfrm>
-          <a:prstGeom prst="rect">
-            <a:avLst/>
-          </a:prstGeom>
-          <a:noFill/>
-          <a:ln w="9525">
-            <a:noFill/>
-            <a:miter lim="800000"/>
-            <a:headEnd/>
-            <a:tailEnd/>
-          </a:ln>
-        </p:spPr>
-        <p:txBody>
-          <a:bodyPr wrap="square" lIns="91440" tIns="45720" rIns="54000" bIns="45720" anchor="t">
-            <a:spAutoFit/>
-          </a:bodyPr>
-          <a:lstStyle/>
-          <a:p>
-            <a:r>
-              <a:rPr lang="de-AT"/>
-              <a:t>Stand: 26.02.2026</a:t>
-            </a:r>
-          </a:p>
-        </p:txBody>
-      </p:sp>
-      <p:sp>
-        <p:nvSpPr>
-          <p:cNvPr id="5" name="Text Box 1030">
-            <a:extLst>
-              <a:ext uri="{FF2B5EF4-FFF2-40B4-BE49-F238E27FC236}">
-                <a16:creationId xmlns:a16="http://schemas.microsoft.com/office/drawing/2014/main" id="{53066329-D502-D77A-238D-8E6D8736BC60}"/>
-              </a:ext>
-            </a:extLst>
-          </p:cNvPr>
-          <p:cNvSpPr txBox="1">
-            <a:spLocks noChangeArrowheads="1"/>
-          </p:cNvSpPr>
-          <p:nvPr/>
-        </p:nvSpPr>
-        <p:spPr bwMode="auto">
-          <a:xfrm>
-            <a:off x="4589380" y="5400124"/>
-            <a:ext cx="3013236" cy="646331"/>
-          </a:xfrm>
-          <a:prstGeom prst="rect">
-            <a:avLst/>
-          </a:prstGeom>
-          <a:noFill/>
-          <a:ln w="9525">
-            <a:noFill/>
-            <a:miter lim="800000"/>
-            <a:headEnd/>
-            <a:tailEnd/>
-          </a:ln>
-        </p:spPr>
-        <p:txBody>
-          <a:bodyPr wrap="square" lIns="91440" tIns="45720" rIns="54000" bIns="45720" anchor="t">
-            <a:spAutoFit/>
-          </a:bodyPr>
-          <a:lstStyle>
-            <a:defPPr>
-              <a:defRPr lang="de-DE"/>
-            </a:defPPr>
-            <a:lvl1pPr marL="0" algn="l" defTabSz="914400" rtl="0" eaLnBrk="1" latinLnBrk="0" hangingPunct="1">
-              <a:defRPr sz="1800" kern="1200">
-                <a:solidFill>
-                  <a:schemeClr val="tx1"/>
-                </a:solidFill>
-                <a:latin typeface="+mn-lt"/>
-                <a:ea typeface="+mn-ea"/>
-                <a:cs typeface="+mn-cs"/>
-              </a:defRPr>
-            </a:lvl1pPr>
-            <a:lvl2pPr marL="457200" algn="l" defTabSz="914400" rtl="0" eaLnBrk="1" latinLnBrk="0" hangingPunct="1">
-              <a:defRPr sz="1800" kern="1200">
-                <a:solidFill>
-                  <a:schemeClr val="tx1"/>
-                </a:solidFill>
-                <a:latin typeface="+mn-lt"/>
-                <a:ea typeface="+mn-ea"/>
-                <a:cs typeface="+mn-cs"/>
-              </a:defRPr>
-            </a:lvl2pPr>
-            <a:lvl3pPr marL="914400" algn="l" defTabSz="914400" rtl="0" eaLnBrk="1" latinLnBrk="0" hangingPunct="1">
-              <a:defRPr sz="1800" kern="1200">
-                <a:solidFill>
-                  <a:schemeClr val="tx1"/>
-                </a:solidFill>
-                <a:latin typeface="+mn-lt"/>
-                <a:ea typeface="+mn-ea"/>
-                <a:cs typeface="+mn-cs"/>
-              </a:defRPr>
-            </a:lvl3pPr>
-            <a:lvl4pPr marL="1371600" algn="l" defTabSz="914400" rtl="0" eaLnBrk="1" latinLnBrk="0" hangingPunct="1">
-              <a:defRPr sz="1800" kern="1200">
-                <a:solidFill>
-                  <a:schemeClr val="tx1"/>
-                </a:solidFill>
-                <a:latin typeface="+mn-lt"/>
-                <a:ea typeface="+mn-ea"/>
-                <a:cs typeface="+mn-cs"/>
-              </a:defRPr>
-            </a:lvl4pPr>
-            <a:lvl5pPr marL="1828800" algn="l" defTabSz="914400" rtl="0" eaLnBrk="1" latinLnBrk="0" hangingPunct="1">
-              <a:defRPr sz="1800" kern="1200">
-                <a:solidFill>
-                  <a:schemeClr val="tx1"/>
-                </a:solidFill>
-                <a:latin typeface="+mn-lt"/>
-                <a:ea typeface="+mn-ea"/>
-                <a:cs typeface="+mn-cs"/>
-              </a:defRPr>
-            </a:lvl5pPr>
-            <a:lvl6pPr marL="2286000" algn="l" defTabSz="914400" rtl="0" eaLnBrk="1" latinLnBrk="0" hangingPunct="1">
-              <a:defRPr sz="1800" kern="1200">
-                <a:solidFill>
-                  <a:schemeClr val="tx1"/>
-                </a:solidFill>
-                <a:latin typeface="+mn-lt"/>
-                <a:ea typeface="+mn-ea"/>
-                <a:cs typeface="+mn-cs"/>
-              </a:defRPr>
-            </a:lvl6pPr>
-            <a:lvl7pPr marL="2743200" algn="l" defTabSz="914400" rtl="0" eaLnBrk="1" latinLnBrk="0" hangingPunct="1">
-              <a:defRPr sz="1800" kern="1200">
-                <a:solidFill>
-                  <a:schemeClr val="tx1"/>
-                </a:solidFill>
-                <a:latin typeface="+mn-lt"/>
-                <a:ea typeface="+mn-ea"/>
-                <a:cs typeface="+mn-cs"/>
-              </a:defRPr>
-            </a:lvl7pPr>
-            <a:lvl8pPr marL="3200400" algn="l" defTabSz="914400" rtl="0" eaLnBrk="1" latinLnBrk="0" hangingPunct="1">
-              <a:defRPr sz="1800" kern="1200">
-                <a:solidFill>
-                  <a:schemeClr val="tx1"/>
-                </a:solidFill>
-                <a:latin typeface="+mn-lt"/>
-                <a:ea typeface="+mn-ea"/>
-                <a:cs typeface="+mn-cs"/>
-              </a:defRPr>
-            </a:lvl8pPr>
-            <a:lvl9pPr marL="3657600" algn="l" defTabSz="914400" rtl="0" eaLnBrk="1" latinLnBrk="0" hangingPunct="1">
-              <a:defRPr sz="1800" kern="1200">
-                <a:solidFill>
-                  <a:schemeClr val="tx1"/>
-                </a:solidFill>
-                <a:latin typeface="+mn-lt"/>
-                <a:ea typeface="+mn-ea"/>
-                <a:cs typeface="+mn-cs"/>
-              </a:defRPr>
-            </a:lvl9pPr>
-          </a:lstStyle>
-          <a:p>
-            <a:pPr algn="r"/>
-            <a:r>
-              <a:rPr lang="de-AT"/>
-              <a:t>Betreuer: Markus Zacharias</a:t>
-            </a:r>
-          </a:p>
-          <a:p>
-            <a:pPr algn="r"/>
-            <a:r>
-              <a:rPr lang="de-AT">
-                <a:ea typeface="Calibri"/>
-                <a:cs typeface="Calibri"/>
-              </a:rPr>
-              <a:t>Firmenpartner: HTL Leoben</a:t>
-            </a:r>
-          </a:p>
-        </p:txBody>
-      </p:sp>
+      </p:pic>
     </p:spTree>
     <p:extLst>
       <p:ext uri="{BB962C8B-B14F-4D97-AF65-F5344CB8AC3E}">
-        <p14:creationId xmlns:p14="http://schemas.microsoft.com/office/powerpoint/2010/main" val="1719908370"/>
+        <p14:creationId xmlns:p14="http://schemas.microsoft.com/office/powerpoint/2010/main" val="2991575151"/>
       </p:ext>
     </p:extLst>
   </p:cSld>

</xml_diff>